<commit_message>
update project presentation deck
</commit_message>
<xml_diff>
--- a/outputs/presentation/cover_glass_quality_portfolio.pptx
+++ b/outputs/presentation/cover_glass_quality_portfolio.pptx
@@ -4,28 +4,31 @@
   <p:sldMasterIdLst>
     <p:sldMasterId id="2147483648" r:id="rId1"/>
   </p:sldMasterIdLst>
+  <p:notesMasterIdLst>
+    <p:notesMasterId r:id="rId21"/>
+  </p:notesMasterIdLst>
   <p:sldIdLst>
-    <p:sldId id="256" r:id="rId7"/>
-    <p:sldId id="257" r:id="rId9"/>
-    <p:sldId id="258" r:id="rId10"/>
-    <p:sldId id="259" r:id="rId11"/>
-    <p:sldId id="260" r:id="rId12"/>
-    <p:sldId id="261" r:id="rId13"/>
-    <p:sldId id="262" r:id="rId14"/>
-    <p:sldId id="263" r:id="rId15"/>
-    <p:sldId id="264" r:id="rId16"/>
-    <p:sldId id="265" r:id="rId17"/>
-    <p:sldId id="266" r:id="rId18"/>
-    <p:sldId id="267" r:id="rId19"/>
-    <p:sldId id="268" r:id="rId20"/>
-    <p:sldId id="269" r:id="rId21"/>
-    <p:sldId id="270" r:id="rId22"/>
-    <p:sldId id="271" r:id="rId23"/>
-    <p:sldId id="272" r:id="rId24"/>
-    <p:sldId id="273" r:id="rId25"/>
-    <p:sldId id="274" r:id="rId26"/>
+    <p:sldId id="256" r:id="rId2"/>
+    <p:sldId id="257" r:id="rId3"/>
+    <p:sldId id="258" r:id="rId4"/>
+    <p:sldId id="259" r:id="rId5"/>
+    <p:sldId id="260" r:id="rId6"/>
+    <p:sldId id="261" r:id="rId7"/>
+    <p:sldId id="262" r:id="rId8"/>
+    <p:sldId id="263" r:id="rId9"/>
+    <p:sldId id="264" r:id="rId10"/>
+    <p:sldId id="265" r:id="rId11"/>
+    <p:sldId id="266" r:id="rId12"/>
+    <p:sldId id="267" r:id="rId13"/>
+    <p:sldId id="268" r:id="rId14"/>
+    <p:sldId id="269" r:id="rId15"/>
+    <p:sldId id="270" r:id="rId16"/>
+    <p:sldId id="271" r:id="rId17"/>
+    <p:sldId id="272" r:id="rId18"/>
+    <p:sldId id="273" r:id="rId19"/>
+    <p:sldId id="274" r:id="rId20"/>
   </p:sldIdLst>
-  <p:sldSz cx="12191695" cy="6858000" type="screen4x3"/>
+  <p:sldSz cx="12192000" cy="6858000"/>
   <p:notesSz cx="6858000" cy="9144000"/>
   <p:defaultTextStyle>
     <a:defPPr>
@@ -122,11 +125,27 @@
       </a:defRPr>
     </a:lvl9pPr>
   </p:defaultTextStyle>
+  <p:extLst>
+    <p:ext uri="{EFAFB233-063F-42B5-8137-9DF3F51BA10A}">
+      <p15:sldGuideLst xmlns:p15="http://schemas.microsoft.com/office/powerpoint/2012/main">
+        <p15:guide id="1" orient="horz" pos="2160">
+          <p15:clr>
+            <a:srgbClr val="A4A3A4"/>
+          </p15:clr>
+        </p15:guide>
+        <p15:guide id="2" pos="2880">
+          <p15:clr>
+            <a:srgbClr val="A4A3A4"/>
+          </p15:clr>
+        </p15:guide>
+      </p15:sldGuideLst>
+    </p:ext>
+  </p:extLst>
 </p:presentation>
 </file>
 
 <file path=ppt/notesMasters/notesMaster1.xml><?xml version="1.0" encoding="utf-8"?>
-<p:notesMaster xmlns:a="http://schemas.openxmlformats.org/drawingml/2006/main" xmlns:p="http://schemas.openxmlformats.org/presentationml/2006/main" xmlns:r="http://schemas.openxmlformats.org/officeDocument/2006/relationships">
+<p:notesMaster xmlns:a="http://schemas.openxmlformats.org/drawingml/2006/main" xmlns:r="http://schemas.openxmlformats.org/officeDocument/2006/relationships" xmlns:p="http://schemas.openxmlformats.org/presentationml/2006/main">
   <p:cSld>
     <p:bg>
       <p:bgRef idx="1001">
@@ -147,241 +166,16 @@
           <a:chExt cx="0" cy="0"/>
         </a:xfrm>
       </p:grpSpPr>
-      <p:sp>
-        <p:nvSpPr>
-          <p:cNvPr id="2" name="Header Placeholder 1"/>
-          <p:cNvSpPr>
-            <a:spLocks noGrp="1"/>
-          </p:cNvSpPr>
-          <p:nvPr>
-            <p:ph type="hdr" sz="quarter"/>
-          </p:nvPr>
-        </p:nvSpPr>
-        <p:spPr>
-          <a:xfrm>
-            <a:off x="0" y="0"/>
-            <a:ext cx="2971800" cy="457200"/>
-          </a:xfrm>
-          <a:prstGeom prst="rect">
-            <a:avLst/>
-          </a:prstGeom>
-        </p:spPr>
-        <p:txBody>
-          <a:bodyPr vert="horz" lIns="91440" tIns="45720" rIns="91440" bIns="45720" rtlCol="0"/>
-          <a:lstStyle>
-            <a:lvl1pPr algn="l">
-              <a:defRPr sz="1200"/>
-            </a:lvl1pPr>
-          </a:lstStyle>
-          <a:p>
-            <a:endParaRPr lang="en-US"/>
-          </a:p>
-        </p:txBody>
-      </p:sp>
-      <p:sp>
-        <p:nvSpPr>
-          <p:cNvPr id="3" name="Date Placeholder 2"/>
-          <p:cNvSpPr>
-            <a:spLocks noGrp="1"/>
-          </p:cNvSpPr>
-          <p:nvPr>
-            <p:ph type="dt" idx="1"/>
-          </p:nvPr>
-        </p:nvSpPr>
-        <p:spPr>
-          <a:xfrm>
-            <a:off x="3884613" y="0"/>
-            <a:ext cx="2971800" cy="457200"/>
-          </a:xfrm>
-          <a:prstGeom prst="rect">
-            <a:avLst/>
-          </a:prstGeom>
-        </p:spPr>
-        <p:txBody>
-          <a:bodyPr vert="horz" lIns="91440" tIns="45720" rIns="91440" bIns="45720" rtlCol="0"/>
-          <a:lstStyle>
-            <a:lvl1pPr algn="r">
-              <a:defRPr sz="1200"/>
-            </a:lvl1pPr>
-          </a:lstStyle>
-          <a:p>
-            <a:fld id="{0F89C1C7-3DCD-1040-A9CF-14679D8B5DDD}" type="datetimeFigureOut">
-              <a:rPr lang="en-US" smtClean="0"/>
-              <a:t>10/17/16</a:t>
-            </a:fld>
-            <a:endParaRPr lang="en-US"/>
-          </a:p>
-        </p:txBody>
-      </p:sp>
-      <p:sp>
-        <p:nvSpPr>
-          <p:cNvPr id="4" name="Slide Image Placeholder 3"/>
-          <p:cNvSpPr>
-            <a:spLocks noGrp="1" noRot="1" noChangeAspect="1"/>
-          </p:cNvSpPr>
-          <p:nvPr>
-            <p:ph type="sldImg" idx="2"/>
-          </p:nvPr>
-        </p:nvSpPr>
-        <p:spPr>
-          <a:xfrm>
-            <a:off x="1143000" y="685800"/>
-            <a:ext cx="4572000" cy="3429000"/>
-          </a:xfrm>
-          <a:prstGeom prst="rect">
-            <a:avLst/>
-          </a:prstGeom>
-          <a:noFill/>
-          <a:ln w="12700">
-            <a:solidFill>
-              <a:prstClr val="black"/>
-            </a:solidFill>
-          </a:ln>
-        </p:spPr>
-        <p:txBody>
-          <a:bodyPr vert="horz" lIns="91440" tIns="45720" rIns="91440" bIns="45720" rtlCol="0" anchor="ctr"/>
-          <a:lstStyle/>
-          <a:p>
-            <a:endParaRPr lang="en-US"/>
-          </a:p>
-        </p:txBody>
-      </p:sp>
-      <p:sp>
-        <p:nvSpPr>
-          <p:cNvPr id="5" name="Notes Placeholder 4"/>
-          <p:cNvSpPr>
-            <a:spLocks noGrp="1"/>
-          </p:cNvSpPr>
-          <p:nvPr>
-            <p:ph type="body" sz="quarter" idx="3"/>
-          </p:nvPr>
-        </p:nvSpPr>
-        <p:spPr>
-          <a:xfrm>
-            <a:off x="685800" y="4343400"/>
-            <a:ext cx="5486400" cy="4114800"/>
-          </a:xfrm>
-          <a:prstGeom prst="rect">
-            <a:avLst/>
-          </a:prstGeom>
-        </p:spPr>
-        <p:txBody>
-          <a:bodyPr vert="horz" lIns="91440" tIns="45720" rIns="91440" bIns="45720" rtlCol="0"/>
-          <a:lstStyle/>
-          <a:p>
-            <a:pPr lvl="0"/>
-            <a:r>
-              <a:rPr lang="en-US" smtClean="0"/>
-              <a:t>Click to edit Master text styles</a:t>
-            </a:r>
-          </a:p>
-          <a:p>
-            <a:pPr lvl="1"/>
-            <a:r>
-              <a:rPr lang="en-US" smtClean="0"/>
-              <a:t>Second level</a:t>
-            </a:r>
-          </a:p>
-          <a:p>
-            <a:pPr lvl="2"/>
-            <a:r>
-              <a:rPr lang="en-US" smtClean="0"/>
-              <a:t>Third level</a:t>
-            </a:r>
-          </a:p>
-          <a:p>
-            <a:pPr lvl="3"/>
-            <a:r>
-              <a:rPr lang="en-US" smtClean="0"/>
-              <a:t>Fourth level</a:t>
-            </a:r>
-          </a:p>
-          <a:p>
-            <a:pPr lvl="4"/>
-            <a:r>
-              <a:rPr lang="en-US" smtClean="0"/>
-              <a:t>Fifth level</a:t>
-            </a:r>
-            <a:endParaRPr lang="en-US"/>
-          </a:p>
-        </p:txBody>
-      </p:sp>
-      <p:sp>
-        <p:nvSpPr>
-          <p:cNvPr id="6" name="Footer Placeholder 5"/>
-          <p:cNvSpPr>
-            <a:spLocks noGrp="1"/>
-          </p:cNvSpPr>
-          <p:nvPr>
-            <p:ph type="ftr" sz="quarter" idx="4"/>
-          </p:nvPr>
-        </p:nvSpPr>
-        <p:spPr>
-          <a:xfrm>
-            <a:off x="0" y="8685213"/>
-            <a:ext cx="2971800" cy="457200"/>
-          </a:xfrm>
-          <a:prstGeom prst="rect">
-            <a:avLst/>
-          </a:prstGeom>
-        </p:spPr>
-        <p:txBody>
-          <a:bodyPr vert="horz" lIns="91440" tIns="45720" rIns="91440" bIns="45720" rtlCol="0" anchor="b"/>
-          <a:lstStyle>
-            <a:lvl1pPr algn="l">
-              <a:defRPr sz="1200"/>
-            </a:lvl1pPr>
-          </a:lstStyle>
-          <a:p>
-            <a:endParaRPr lang="en-US"/>
-          </a:p>
-        </p:txBody>
-      </p:sp>
-      <p:sp>
-        <p:nvSpPr>
-          <p:cNvPr id="7" name="Slide Number Placeholder 6"/>
-          <p:cNvSpPr>
-            <a:spLocks noGrp="1"/>
-          </p:cNvSpPr>
-          <p:nvPr>
-            <p:ph type="sldNum" sz="quarter" idx="5"/>
-          </p:nvPr>
-        </p:nvSpPr>
-        <p:spPr>
-          <a:xfrm>
-            <a:off x="3884613" y="8685213"/>
-            <a:ext cx="2971800" cy="457200"/>
-          </a:xfrm>
-          <a:prstGeom prst="rect">
-            <a:avLst/>
-          </a:prstGeom>
-        </p:spPr>
-        <p:txBody>
-          <a:bodyPr vert="horz" lIns="91440" tIns="45720" rIns="91440" bIns="45720" rtlCol="0" anchor="b"/>
-          <a:lstStyle>
-            <a:lvl1pPr algn="r">
-              <a:defRPr sz="1200"/>
-            </a:lvl1pPr>
-          </a:lstStyle>
-          <a:p>
-            <a:fld id="{BB5E49A5-4136-284D-997B-48E1D791AD67}" type="slidenum">
-              <a:rPr lang="en-US" smtClean="0"/>
-              <a:t>‹#›</a:t>
-            </a:fld>
-            <a:endParaRPr lang="en-US"/>
-          </a:p>
-        </p:txBody>
-      </p:sp>
     </p:spTree>
     <p:extLst>
       <p:ext uri="{BB962C8B-B14F-4D97-AF65-F5344CB8AC3E}">
-        <p14:creationId xmlns:p14="http://schemas.microsoft.com/office/powerpoint/2010/main" val="2623252185"/>
+        <p14:creationId xmlns:p14="http://schemas.microsoft.com/office/powerpoint/2010/main" val="712815686"/>
       </p:ext>
     </p:extLst>
   </p:cSld>
   <p:clrMap bg1="lt1" tx1="dk1" bg2="lt2" tx2="dk2" accent1="accent1" accent2="accent2" accent3="accent3" accent4="accent4" accent5="accent5" accent6="accent6" hlink="hlink" folHlink="folHlink"/>
   <p:notesStyle>
-    <a:lvl1pPr marL="0" algn="l" defTabSz="457200" rtl="0" eaLnBrk="1" latinLnBrk="0" hangingPunct="1">
+    <a:lvl1pPr marL="0" algn="l" defTabSz="914400" rtl="0" eaLnBrk="1" latinLnBrk="0" hangingPunct="1">
       <a:defRPr sz="1200" kern="1200">
         <a:solidFill>
           <a:schemeClr val="tx1"/>
@@ -391,7 +185,7 @@
         <a:cs typeface="+mn-cs"/>
       </a:defRPr>
     </a:lvl1pPr>
-    <a:lvl2pPr marL="457200" algn="l" defTabSz="457200" rtl="0" eaLnBrk="1" latinLnBrk="0" hangingPunct="1">
+    <a:lvl2pPr marL="457200" algn="l" defTabSz="914400" rtl="0" eaLnBrk="1" latinLnBrk="0" hangingPunct="1">
       <a:defRPr sz="1200" kern="1200">
         <a:solidFill>
           <a:schemeClr val="tx1"/>
@@ -401,7 +195,7 @@
         <a:cs typeface="+mn-cs"/>
       </a:defRPr>
     </a:lvl2pPr>
-    <a:lvl3pPr marL="914400" algn="l" defTabSz="457200" rtl="0" eaLnBrk="1" latinLnBrk="0" hangingPunct="1">
+    <a:lvl3pPr marL="914400" algn="l" defTabSz="914400" rtl="0" eaLnBrk="1" latinLnBrk="0" hangingPunct="1">
       <a:defRPr sz="1200" kern="1200">
         <a:solidFill>
           <a:schemeClr val="tx1"/>
@@ -411,7 +205,7 @@
         <a:cs typeface="+mn-cs"/>
       </a:defRPr>
     </a:lvl3pPr>
-    <a:lvl4pPr marL="1371600" algn="l" defTabSz="457200" rtl="0" eaLnBrk="1" latinLnBrk="0" hangingPunct="1">
+    <a:lvl4pPr marL="1371600" algn="l" defTabSz="914400" rtl="0" eaLnBrk="1" latinLnBrk="0" hangingPunct="1">
       <a:defRPr sz="1200" kern="1200">
         <a:solidFill>
           <a:schemeClr val="tx1"/>
@@ -421,7 +215,7 @@
         <a:cs typeface="+mn-cs"/>
       </a:defRPr>
     </a:lvl4pPr>
-    <a:lvl5pPr marL="1828800" algn="l" defTabSz="457200" rtl="0" eaLnBrk="1" latinLnBrk="0" hangingPunct="1">
+    <a:lvl5pPr marL="1828800" algn="l" defTabSz="914400" rtl="0" eaLnBrk="1" latinLnBrk="0" hangingPunct="1">
       <a:defRPr sz="1200" kern="1200">
         <a:solidFill>
           <a:schemeClr val="tx1"/>
@@ -431,7 +225,7 @@
         <a:cs typeface="+mn-cs"/>
       </a:defRPr>
     </a:lvl5pPr>
-    <a:lvl6pPr marL="2286000" algn="l" defTabSz="457200" rtl="0" eaLnBrk="1" latinLnBrk="0" hangingPunct="1">
+    <a:lvl6pPr marL="2286000" algn="l" defTabSz="914400" rtl="0" eaLnBrk="1" latinLnBrk="0" hangingPunct="1">
       <a:defRPr sz="1200" kern="1200">
         <a:solidFill>
           <a:schemeClr val="tx1"/>
@@ -441,7 +235,7 @@
         <a:cs typeface="+mn-cs"/>
       </a:defRPr>
     </a:lvl6pPr>
-    <a:lvl7pPr marL="2743200" algn="l" defTabSz="457200" rtl="0" eaLnBrk="1" latinLnBrk="0" hangingPunct="1">
+    <a:lvl7pPr marL="2743200" algn="l" defTabSz="914400" rtl="0" eaLnBrk="1" latinLnBrk="0" hangingPunct="1">
       <a:defRPr sz="1200" kern="1200">
         <a:solidFill>
           <a:schemeClr val="tx1"/>
@@ -451,7 +245,7 @@
         <a:cs typeface="+mn-cs"/>
       </a:defRPr>
     </a:lvl7pPr>
-    <a:lvl8pPr marL="3200400" algn="l" defTabSz="457200" rtl="0" eaLnBrk="1" latinLnBrk="0" hangingPunct="1">
+    <a:lvl8pPr marL="3200400" algn="l" defTabSz="914400" rtl="0" eaLnBrk="1" latinLnBrk="0" hangingPunct="1">
       <a:defRPr sz="1200" kern="1200">
         <a:solidFill>
           <a:schemeClr val="tx1"/>
@@ -461,7 +255,7 @@
         <a:cs typeface="+mn-cs"/>
       </a:defRPr>
     </a:lvl8pPr>
-    <a:lvl9pPr marL="3657600" algn="l" defTabSz="457200" rtl="0" eaLnBrk="1" latinLnBrk="0" hangingPunct="1">
+    <a:lvl9pPr marL="3657600" algn="l" defTabSz="914400" rtl="0" eaLnBrk="1" latinLnBrk="0" hangingPunct="1">
       <a:defRPr sz="1200" kern="1200">
         <a:solidFill>
           <a:schemeClr val="tx1"/>
@@ -476,7 +270,7 @@
 </file>
 
 <file path=ppt/notesSlides/notesSlide1.xml><?xml version="1.0" encoding="utf-8"?>
-<p:notes xmlns:a="http://schemas.openxmlformats.org/drawingml/2006/main" xmlns:p="http://schemas.openxmlformats.org/presentationml/2006/main" xmlns:r="http://schemas.openxmlformats.org/officeDocument/2006/relationships">
+<p:notes xmlns:a="http://schemas.openxmlformats.org/drawingml/2006/main" xmlns:r="http://schemas.openxmlformats.org/officeDocument/2006/relationships" xmlns:p="http://schemas.openxmlformats.org/presentationml/2006/main">
   <p:cSld>
     <p:spTree>
       <p:nvGrpSpPr>
@@ -496,43 +290,45 @@
         <p:nvSpPr>
           <p:cNvPr id="2" name="Slide Image Placeholder 1"/>
           <p:cNvSpPr>
+            <a:spLocks noGrp="1" noRot="1" noChangeAspect="1"/>
+          </p:cNvSpPr>
+          <p:nvPr>
+            <p:ph type="sldImg" idx="2"/>
+          </p:nvPr>
+        </p:nvSpPr>
+        <p:spPr/>
+      </p:sp>
+      <p:sp>
+        <p:nvSpPr>
+          <p:cNvPr id="3" name="Notes Placeholder 2"/>
+          <p:cNvSpPr>
             <a:spLocks noGrp="1"/>
           </p:cNvSpPr>
           <p:nvPr>
-            <p:ph type="sldImg" idx="2"/>
+            <p:ph type="body" sz="quarter" idx="3"/>
           </p:nvPr>
         </p:nvSpPr>
         <p:spPr/>
-      </p:sp>
-      <p:sp>
-        <p:nvSpPr>
-          <p:cNvPr id="3" name="Notes Placeholder 2"/>
+        <p:txBody>
+          <a:bodyPr/>
+          <a:lstStyle/>
+          <a:p>
+            <a:r>
+              <a:rPr lang="en-US"/>
+              <a:t>I'm walking through a simulated cover-glass yield excursion. All data is synthetic — this is not Apple or supplier confidential data.</a:t>
+            </a:r>
+            <a:endParaRPr lang="en-US" dirty="0"/>
+          </a:p>
+        </p:txBody>
+      </p:sp>
+      <p:sp>
+        <p:nvSpPr>
+          <p:cNvPr id="4" name="Slide Number Placeholder 3"/>
           <p:cNvSpPr>
             <a:spLocks noGrp="1"/>
           </p:cNvSpPr>
           <p:nvPr>
-            <p:ph type="body" idx="3" sz="quarter"/>
-          </p:nvPr>
-        </p:nvSpPr>
-        <p:spPr/>
-        <p:txBody>
-          <a:bodyPr/>
-          <a:lstStyle/>
-          <a:p>
-            <a:r>
-              <a:t>I'm walking through a simulated cover-glass yield excursion. All data is synthetic — this is not Apple or supplier confidential data.</a:t>
-            </a:r>
-          </a:p>
-        </p:txBody>
-      </p:sp>
-      <p:sp>
-        <p:nvSpPr>
-          <p:cNvPr id="4" name="Slide Number Placeholder 3"/>
-          <p:cNvSpPr>
-            <a:spLocks noGrp="1"/>
-          </p:cNvSpPr>
-          <p:nvPr>
-            <p:ph type="sldNum" idx="5" sz="quarter"/>
+            <p:ph type="sldNum" sz="quarter" idx="5"/>
           </p:nvPr>
         </p:nvSpPr>
         <p:spPr/>
@@ -546,7 +342,7 @@
 </file>
 
 <file path=ppt/notesSlides/notesSlide10.xml><?xml version="1.0" encoding="utf-8"?>
-<p:notes xmlns:a="http://schemas.openxmlformats.org/drawingml/2006/main" xmlns:p="http://schemas.openxmlformats.org/presentationml/2006/main" xmlns:r="http://schemas.openxmlformats.org/officeDocument/2006/relationships">
+<p:notes xmlns:a="http://schemas.openxmlformats.org/drawingml/2006/main" xmlns:r="http://schemas.openxmlformats.org/officeDocument/2006/relationships" xmlns:p="http://schemas.openxmlformats.org/presentationml/2006/main">
   <p:cSld>
     <p:spTree>
       <p:nvGrpSpPr>
@@ -566,43 +362,44 @@
         <p:nvSpPr>
           <p:cNvPr id="2" name="Slide Image Placeholder 1"/>
           <p:cNvSpPr>
+            <a:spLocks noGrp="1" noRot="1" noChangeAspect="1"/>
+          </p:cNvSpPr>
+          <p:nvPr>
+            <p:ph type="sldImg" idx="2"/>
+          </p:nvPr>
+        </p:nvSpPr>
+        <p:spPr/>
+      </p:sp>
+      <p:sp>
+        <p:nvSpPr>
+          <p:cNvPr id="3" name="Notes Placeholder 2"/>
+          <p:cNvSpPr>
             <a:spLocks noGrp="1"/>
           </p:cNvSpPr>
           <p:nvPr>
-            <p:ph type="sldImg" idx="2"/>
+            <p:ph type="body" sz="quarter" idx="3"/>
           </p:nvPr>
         </p:nvSpPr>
         <p:spPr/>
-      </p:sp>
-      <p:sp>
-        <p:nvSpPr>
-          <p:cNvPr id="3" name="Notes Placeholder 2"/>
+        <p:txBody>
+          <a:bodyPr/>
+          <a:lstStyle/>
+          <a:p>
+            <a:r>
+              <a:rPr dirty="0"/>
+              <a:t>When tool life is critical and coolant is unstable, chipping jumps to 61.5%. I didn't bake this into the headline — stratification rediscovered it.</a:t>
+            </a:r>
+          </a:p>
+        </p:txBody>
+      </p:sp>
+      <p:sp>
+        <p:nvSpPr>
+          <p:cNvPr id="4" name="Slide Number Placeholder 3"/>
           <p:cNvSpPr>
             <a:spLocks noGrp="1"/>
           </p:cNvSpPr>
           <p:nvPr>
-            <p:ph type="body" idx="3" sz="quarter"/>
-          </p:nvPr>
-        </p:nvSpPr>
-        <p:spPr/>
-        <p:txBody>
-          <a:bodyPr/>
-          <a:lstStyle/>
-          <a:p>
-            <a:r>
-              <a:t>This is the money slide. When tool life is critical and coolant is unstable, chipping jumps to 61.5%. I didn't bake this into the headline — stratification rediscovered it.</a:t>
-            </a:r>
-          </a:p>
-        </p:txBody>
-      </p:sp>
-      <p:sp>
-        <p:nvSpPr>
-          <p:cNvPr id="4" name="Slide Number Placeholder 3"/>
-          <p:cNvSpPr>
-            <a:spLocks noGrp="1"/>
-          </p:cNvSpPr>
-          <p:nvPr>
-            <p:ph type="sldNum" idx="5" sz="quarter"/>
+            <p:ph type="sldNum" sz="quarter" idx="5"/>
           </p:nvPr>
         </p:nvSpPr>
         <p:spPr/>
@@ -616,7 +413,7 @@
 </file>
 
 <file path=ppt/notesSlides/notesSlide11.xml><?xml version="1.0" encoding="utf-8"?>
-<p:notes xmlns:a="http://schemas.openxmlformats.org/drawingml/2006/main" xmlns:p="http://schemas.openxmlformats.org/presentationml/2006/main" xmlns:r="http://schemas.openxmlformats.org/officeDocument/2006/relationships">
+<p:notes xmlns:a="http://schemas.openxmlformats.org/drawingml/2006/main" xmlns:r="http://schemas.openxmlformats.org/officeDocument/2006/relationships" xmlns:p="http://schemas.openxmlformats.org/presentationml/2006/main">
   <p:cSld>
     <p:spTree>
       <p:nvGrpSpPr>
@@ -636,43 +433,44 @@
         <p:nvSpPr>
           <p:cNvPr id="2" name="Slide Image Placeholder 1"/>
           <p:cNvSpPr>
+            <a:spLocks noGrp="1" noRot="1" noChangeAspect="1"/>
+          </p:cNvSpPr>
+          <p:nvPr>
+            <p:ph type="sldImg" idx="2"/>
+          </p:nvPr>
+        </p:nvSpPr>
+        <p:spPr/>
+      </p:sp>
+      <p:sp>
+        <p:nvSpPr>
+          <p:cNvPr id="3" name="Notes Placeholder 2"/>
+          <p:cNvSpPr>
             <a:spLocks noGrp="1"/>
           </p:cNvSpPr>
           <p:nvPr>
-            <p:ph type="sldImg" idx="2"/>
+            <p:ph type="body" sz="quarter" idx="3"/>
           </p:nvPr>
         </p:nvSpPr>
         <p:spPr/>
-      </p:sp>
-      <p:sp>
-        <p:nvSpPr>
-          <p:cNvPr id="3" name="Notes Placeholder 2"/>
+        <p:txBody>
+          <a:bodyPr/>
+          <a:lstStyle/>
+          <a:p>
+            <a:r>
+              <a:rPr dirty="0"/>
+              <a:t>For chipping I prefer the p-chart over I-MR on size because most units are zero.</a:t>
+            </a:r>
+          </a:p>
+        </p:txBody>
+      </p:sp>
+      <p:sp>
+        <p:nvSpPr>
+          <p:cNvPr id="4" name="Slide Number Placeholder 3"/>
           <p:cNvSpPr>
             <a:spLocks noGrp="1"/>
           </p:cNvSpPr>
           <p:nvPr>
-            <p:ph type="body" idx="3" sz="quarter"/>
-          </p:nvPr>
-        </p:nvSpPr>
-        <p:spPr/>
-        <p:txBody>
-          <a:bodyPr/>
-          <a:lstStyle/>
-          <a:p>
-            <a:r>
-              <a:t>SPC answers: is this a special cause or just noisy? For chipping I prefer the p-chart over I-MR on size because most units are zero.</a:t>
-            </a:r>
-          </a:p>
-        </p:txBody>
-      </p:sp>
-      <p:sp>
-        <p:nvSpPr>
-          <p:cNvPr id="4" name="Slide Number Placeholder 3"/>
-          <p:cNvSpPr>
-            <a:spLocks noGrp="1"/>
-          </p:cNvSpPr>
-          <p:nvPr>
-            <p:ph type="sldNum" idx="5" sz="quarter"/>
+            <p:ph type="sldNum" sz="quarter" idx="5"/>
           </p:nvPr>
         </p:nvSpPr>
         <p:spPr/>
@@ -686,7 +484,7 @@
 </file>
 
 <file path=ppt/notesSlides/notesSlide12.xml><?xml version="1.0" encoding="utf-8"?>
-<p:notes xmlns:a="http://schemas.openxmlformats.org/drawingml/2006/main" xmlns:p="http://schemas.openxmlformats.org/presentationml/2006/main" xmlns:r="http://schemas.openxmlformats.org/officeDocument/2006/relationships">
+<p:notes xmlns:a="http://schemas.openxmlformats.org/drawingml/2006/main" xmlns:r="http://schemas.openxmlformats.org/officeDocument/2006/relationships" xmlns:p="http://schemas.openxmlformats.org/presentationml/2006/main">
   <p:cSld>
     <p:spTree>
       <p:nvGrpSpPr>
@@ -706,43 +504,43 @@
         <p:nvSpPr>
           <p:cNvPr id="2" name="Slide Image Placeholder 1"/>
           <p:cNvSpPr>
+            <a:spLocks noGrp="1" noRot="1" noChangeAspect="1"/>
+          </p:cNvSpPr>
+          <p:nvPr>
+            <p:ph type="sldImg" idx="2"/>
+          </p:nvPr>
+        </p:nvSpPr>
+        <p:spPr/>
+      </p:sp>
+      <p:sp>
+        <p:nvSpPr>
+          <p:cNvPr id="3" name="Notes Placeholder 2"/>
+          <p:cNvSpPr>
             <a:spLocks noGrp="1"/>
           </p:cNvSpPr>
           <p:nvPr>
-            <p:ph type="sldImg" idx="2"/>
+            <p:ph type="body" sz="quarter" idx="3"/>
           </p:nvPr>
         </p:nvSpPr>
         <p:spPr/>
-      </p:sp>
-      <p:sp>
-        <p:nvSpPr>
-          <p:cNvPr id="3" name="Notes Placeholder 2"/>
+        <p:txBody>
+          <a:bodyPr/>
+          <a:lstStyle/>
+          <a:p>
+            <a:r>
+              <a:t>Capability tells me spec margin, not just pass/fail. Baseline Cpk is ~1.4; the bad window drops to ~1.18 with a mean shift up.</a:t>
+            </a:r>
+          </a:p>
+        </p:txBody>
+      </p:sp>
+      <p:sp>
+        <p:nvSpPr>
+          <p:cNvPr id="4" name="Slide Number Placeholder 3"/>
           <p:cNvSpPr>
             <a:spLocks noGrp="1"/>
           </p:cNvSpPr>
           <p:nvPr>
-            <p:ph type="body" idx="3" sz="quarter"/>
-          </p:nvPr>
-        </p:nvSpPr>
-        <p:spPr/>
-        <p:txBody>
-          <a:bodyPr/>
-          <a:lstStyle/>
-          <a:p>
-            <a:r>
-              <a:t>Capability tells me spec margin, not just pass/fail. Baseline Cpk is ~1.4; the bad window drops to ~1.18 with a mean shift up.</a:t>
-            </a:r>
-          </a:p>
-        </p:txBody>
-      </p:sp>
-      <p:sp>
-        <p:nvSpPr>
-          <p:cNvPr id="4" name="Slide Number Placeholder 3"/>
-          <p:cNvSpPr>
-            <a:spLocks noGrp="1"/>
-          </p:cNvSpPr>
-          <p:nvPr>
-            <p:ph type="sldNum" idx="5" sz="quarter"/>
+            <p:ph type="sldNum" sz="quarter" idx="5"/>
           </p:nvPr>
         </p:nvSpPr>
         <p:spPr/>
@@ -756,7 +554,7 @@
 </file>
 
 <file path=ppt/notesSlides/notesSlide13.xml><?xml version="1.0" encoding="utf-8"?>
-<p:notes xmlns:a="http://schemas.openxmlformats.org/drawingml/2006/main" xmlns:p="http://schemas.openxmlformats.org/presentationml/2006/main" xmlns:r="http://schemas.openxmlformats.org/officeDocument/2006/relationships">
+<p:notes xmlns:a="http://schemas.openxmlformats.org/drawingml/2006/main" xmlns:r="http://schemas.openxmlformats.org/officeDocument/2006/relationships" xmlns:p="http://schemas.openxmlformats.org/presentationml/2006/main">
   <p:cSld>
     <p:spTree>
       <p:nvGrpSpPr>
@@ -776,43 +574,43 @@
         <p:nvSpPr>
           <p:cNvPr id="2" name="Slide Image Placeholder 1"/>
           <p:cNvSpPr>
+            <a:spLocks noGrp="1" noRot="1" noChangeAspect="1"/>
+          </p:cNvSpPr>
+          <p:nvPr>
+            <p:ph type="sldImg" idx="2"/>
+          </p:nvPr>
+        </p:nvSpPr>
+        <p:spPr/>
+      </p:sp>
+      <p:sp>
+        <p:nvSpPr>
+          <p:cNvPr id="3" name="Notes Placeholder 2"/>
+          <p:cNvSpPr>
             <a:spLocks noGrp="1"/>
           </p:cNvSpPr>
           <p:nvPr>
-            <p:ph type="sldImg" idx="2"/>
+            <p:ph type="body" sz="quarter" idx="3"/>
           </p:nvPr>
         </p:nvSpPr>
         <p:spPr/>
-      </p:sp>
-      <p:sp>
-        <p:nvSpPr>
-          <p:cNvPr id="3" name="Notes Placeholder 2"/>
+        <p:txBody>
+          <a:bodyPr/>
+          <a:lstStyle/>
+          <a:p>
+            <a:r>
+              <a:t>Location pattern is another sanity check. If chipping were random contamination you'd expect a different map.</a:t>
+            </a:r>
+          </a:p>
+        </p:txBody>
+      </p:sp>
+      <p:sp>
+        <p:nvSpPr>
+          <p:cNvPr id="4" name="Slide Number Placeholder 3"/>
           <p:cNvSpPr>
             <a:spLocks noGrp="1"/>
           </p:cNvSpPr>
           <p:nvPr>
-            <p:ph type="body" idx="3" sz="quarter"/>
-          </p:nvPr>
-        </p:nvSpPr>
-        <p:spPr/>
-        <p:txBody>
-          <a:bodyPr/>
-          <a:lstStyle/>
-          <a:p>
-            <a:r>
-              <a:t>Location pattern is another sanity check. If chipping were random contamination you'd expect a different map.</a:t>
-            </a:r>
-          </a:p>
-        </p:txBody>
-      </p:sp>
-      <p:sp>
-        <p:nvSpPr>
-          <p:cNvPr id="4" name="Slide Number Placeholder 3"/>
-          <p:cNvSpPr>
-            <a:spLocks noGrp="1"/>
-          </p:cNvSpPr>
-          <p:nvPr>
-            <p:ph type="sldNum" idx="5" sz="quarter"/>
+            <p:ph type="sldNum" sz="quarter" idx="5"/>
           </p:nvPr>
         </p:nvSpPr>
         <p:spPr/>
@@ -826,7 +624,7 @@
 </file>
 
 <file path=ppt/notesSlides/notesSlide14.xml><?xml version="1.0" encoding="utf-8"?>
-<p:notes xmlns:a="http://schemas.openxmlformats.org/drawingml/2006/main" xmlns:p="http://schemas.openxmlformats.org/presentationml/2006/main" xmlns:r="http://schemas.openxmlformats.org/officeDocument/2006/relationships">
+<p:notes xmlns:a="http://schemas.openxmlformats.org/drawingml/2006/main" xmlns:r="http://schemas.openxmlformats.org/officeDocument/2006/relationships" xmlns:p="http://schemas.openxmlformats.org/presentationml/2006/main">
   <p:cSld>
     <p:spTree>
       <p:nvGrpSpPr>
@@ -846,43 +644,44 @@
         <p:nvSpPr>
           <p:cNvPr id="2" name="Slide Image Placeholder 1"/>
           <p:cNvSpPr>
+            <a:spLocks noGrp="1" noRot="1" noChangeAspect="1"/>
+          </p:cNvSpPr>
+          <p:nvPr>
+            <p:ph type="sldImg" idx="2"/>
+          </p:nvPr>
+        </p:nvSpPr>
+        <p:spPr/>
+      </p:sp>
+      <p:sp>
+        <p:nvSpPr>
+          <p:cNvPr id="3" name="Notes Placeholder 2"/>
+          <p:cNvSpPr>
             <a:spLocks noGrp="1"/>
           </p:cNvSpPr>
           <p:nvPr>
-            <p:ph type="sldImg" idx="2"/>
+            <p:ph type="body" sz="quarter" idx="3"/>
           </p:nvPr>
         </p:nvSpPr>
         <p:spPr/>
-      </p:sp>
-      <p:sp>
-        <p:nvSpPr>
-          <p:cNvPr id="3" name="Notes Placeholder 2"/>
+        <p:txBody>
+          <a:bodyPr/>
+          <a:lstStyle/>
+          <a:p>
+            <a:r>
+              <a:rPr dirty="0"/>
+              <a:t>ML supports the same story as stratification. </a:t>
+            </a:r>
+          </a:p>
+        </p:txBody>
+      </p:sp>
+      <p:sp>
+        <p:nvSpPr>
+          <p:cNvPr id="4" name="Slide Number Placeholder 3"/>
           <p:cNvSpPr>
             <a:spLocks noGrp="1"/>
           </p:cNvSpPr>
           <p:nvPr>
-            <p:ph type="body" idx="3" sz="quarter"/>
-          </p:nvPr>
-        </p:nvSpPr>
-        <p:spPr/>
-        <p:txBody>
-          <a:bodyPr/>
-          <a:lstStyle/>
-          <a:p>
-            <a:r>
-              <a:t>ML supports the same story as stratification. I deliberately excluded chamfer and chipping size from inputs. Use predicted probability for ranking — 0.5 threshold is wrong for a 4% defect rate.</a:t>
-            </a:r>
-          </a:p>
-        </p:txBody>
-      </p:sp>
-      <p:sp>
-        <p:nvSpPr>
-          <p:cNvPr id="4" name="Slide Number Placeholder 3"/>
-          <p:cNvSpPr>
-            <a:spLocks noGrp="1"/>
-          </p:cNvSpPr>
-          <p:nvPr>
-            <p:ph type="sldNum" idx="5" sz="quarter"/>
+            <p:ph type="sldNum" sz="quarter" idx="5"/>
           </p:nvPr>
         </p:nvSpPr>
         <p:spPr/>
@@ -896,7 +695,7 @@
 </file>
 
 <file path=ppt/notesSlides/notesSlide15.xml><?xml version="1.0" encoding="utf-8"?>
-<p:notes xmlns:a="http://schemas.openxmlformats.org/drawingml/2006/main" xmlns:p="http://schemas.openxmlformats.org/presentationml/2006/main" xmlns:r="http://schemas.openxmlformats.org/officeDocument/2006/relationships">
+<p:notes xmlns:a="http://schemas.openxmlformats.org/drawingml/2006/main" xmlns:r="http://schemas.openxmlformats.org/officeDocument/2006/relationships" xmlns:p="http://schemas.openxmlformats.org/presentationml/2006/main">
   <p:cSld>
     <p:spTree>
       <p:nvGrpSpPr>
@@ -916,43 +715,43 @@
         <p:nvSpPr>
           <p:cNvPr id="2" name="Slide Image Placeholder 1"/>
           <p:cNvSpPr>
+            <a:spLocks noGrp="1" noRot="1" noChangeAspect="1"/>
+          </p:cNvSpPr>
+          <p:nvPr>
+            <p:ph type="sldImg" idx="2"/>
+          </p:nvPr>
+        </p:nvSpPr>
+        <p:spPr/>
+      </p:sp>
+      <p:sp>
+        <p:nvSpPr>
+          <p:cNvPr id="3" name="Notes Placeholder 2"/>
+          <p:cNvSpPr>
             <a:spLocks noGrp="1"/>
           </p:cNvSpPr>
           <p:nvPr>
-            <p:ph type="sldImg" idx="2"/>
+            <p:ph type="body" sz="quarter" idx="3"/>
           </p:nvPr>
         </p:nvSpPr>
         <p:spPr/>
-      </p:sp>
-      <p:sp>
-        <p:nvSpPr>
-          <p:cNvPr id="3" name="Notes Placeholder 2"/>
+        <p:txBody>
+          <a:bodyPr/>
+          <a:lstStyle/>
+          <a:p>
+            <a:r>
+              <a:t>In a real review I'd open the JMP project and filter live. Python generated the numbers; JMP lets the team explore together.</a:t>
+            </a:r>
+          </a:p>
+        </p:txBody>
+      </p:sp>
+      <p:sp>
+        <p:nvSpPr>
+          <p:cNvPr id="4" name="Slide Number Placeholder 3"/>
           <p:cNvSpPr>
             <a:spLocks noGrp="1"/>
           </p:cNvSpPr>
           <p:nvPr>
-            <p:ph type="body" idx="3" sz="quarter"/>
-          </p:nvPr>
-        </p:nvSpPr>
-        <p:spPr/>
-        <p:txBody>
-          <a:bodyPr/>
-          <a:lstStyle/>
-          <a:p>
-            <a:r>
-              <a:t>In a real review I'd open the JMP project and filter live. Python generated the numbers; JMP lets the team explore together.</a:t>
-            </a:r>
-          </a:p>
-        </p:txBody>
-      </p:sp>
-      <p:sp>
-        <p:nvSpPr>
-          <p:cNvPr id="4" name="Slide Number Placeholder 3"/>
-          <p:cNvSpPr>
-            <a:spLocks noGrp="1"/>
-          </p:cNvSpPr>
-          <p:nvPr>
-            <p:ph type="sldNum" idx="5" sz="quarter"/>
+            <p:ph type="sldNum" sz="quarter" idx="5"/>
           </p:nvPr>
         </p:nvSpPr>
         <p:spPr/>
@@ -966,7 +765,7 @@
 </file>
 
 <file path=ppt/notesSlides/notesSlide16.xml><?xml version="1.0" encoding="utf-8"?>
-<p:notes xmlns:a="http://schemas.openxmlformats.org/drawingml/2006/main" xmlns:p="http://schemas.openxmlformats.org/presentationml/2006/main" xmlns:r="http://schemas.openxmlformats.org/officeDocument/2006/relationships">
+<p:notes xmlns:a="http://schemas.openxmlformats.org/drawingml/2006/main" xmlns:r="http://schemas.openxmlformats.org/officeDocument/2006/relationships" xmlns:p="http://schemas.openxmlformats.org/presentationml/2006/main">
   <p:cSld>
     <p:spTree>
       <p:nvGrpSpPr>
@@ -986,43 +785,43 @@
         <p:nvSpPr>
           <p:cNvPr id="2" name="Slide Image Placeholder 1"/>
           <p:cNvSpPr>
+            <a:spLocks noGrp="1" noRot="1" noChangeAspect="1"/>
+          </p:cNvSpPr>
+          <p:nvPr>
+            <p:ph type="sldImg" idx="2"/>
+          </p:nvPr>
+        </p:nvSpPr>
+        <p:spPr/>
+      </p:sp>
+      <p:sp>
+        <p:nvSpPr>
+          <p:cNvPr id="3" name="Notes Placeholder 2"/>
+          <p:cNvSpPr>
             <a:spLocks noGrp="1"/>
           </p:cNvSpPr>
           <p:nvPr>
-            <p:ph type="sldImg" idx="2"/>
+            <p:ph type="body" sz="quarter" idx="3"/>
           </p:nvPr>
         </p:nvSpPr>
         <p:spPr/>
-      </p:sp>
-      <p:sp>
-        <p:nvSpPr>
-          <p:cNvPr id="3" name="Notes Placeholder 2"/>
+        <p:txBody>
+          <a:bodyPr/>
+          <a:lstStyle/>
+          <a:p>
+            <a:r>
+              <a:t>Close the loop — containment first so bad material doesn't ship, then corrective on the machines and fixtures that stratified hot, then preventive so it doesn't come back.</a:t>
+            </a:r>
+          </a:p>
+        </p:txBody>
+      </p:sp>
+      <p:sp>
+        <p:nvSpPr>
+          <p:cNvPr id="4" name="Slide Number Placeholder 3"/>
           <p:cNvSpPr>
             <a:spLocks noGrp="1"/>
           </p:cNvSpPr>
           <p:nvPr>
-            <p:ph type="body" idx="3" sz="quarter"/>
-          </p:nvPr>
-        </p:nvSpPr>
-        <p:spPr/>
-        <p:txBody>
-          <a:bodyPr/>
-          <a:lstStyle/>
-          <a:p>
-            <a:r>
-              <a:t>Close the loop — containment first so bad material doesn't ship, then corrective on the machines and fixtures that stratified hot, then preventive so it doesn't come back.</a:t>
-            </a:r>
-          </a:p>
-        </p:txBody>
-      </p:sp>
-      <p:sp>
-        <p:nvSpPr>
-          <p:cNvPr id="4" name="Slide Number Placeholder 3"/>
-          <p:cNvSpPr>
-            <a:spLocks noGrp="1"/>
-          </p:cNvSpPr>
-          <p:nvPr>
-            <p:ph type="sldNum" idx="5" sz="quarter"/>
+            <p:ph type="sldNum" sz="quarter" idx="5"/>
           </p:nvPr>
         </p:nvSpPr>
         <p:spPr/>
@@ -1036,7 +835,7 @@
 </file>
 
 <file path=ppt/notesSlides/notesSlide17.xml><?xml version="1.0" encoding="utf-8"?>
-<p:notes xmlns:a="http://schemas.openxmlformats.org/drawingml/2006/main" xmlns:p="http://schemas.openxmlformats.org/presentationml/2006/main" xmlns:r="http://schemas.openxmlformats.org/officeDocument/2006/relationships">
+<p:notes xmlns:a="http://schemas.openxmlformats.org/drawingml/2006/main" xmlns:r="http://schemas.openxmlformats.org/officeDocument/2006/relationships" xmlns:p="http://schemas.openxmlformats.org/presentationml/2006/main">
   <p:cSld>
     <p:spTree>
       <p:nvGrpSpPr>
@@ -1056,43 +855,44 @@
         <p:nvSpPr>
           <p:cNvPr id="2" name="Slide Image Placeholder 1"/>
           <p:cNvSpPr>
+            <a:spLocks noGrp="1" noRot="1" noChangeAspect="1"/>
+          </p:cNvSpPr>
+          <p:nvPr>
+            <p:ph type="sldImg" idx="2"/>
+          </p:nvPr>
+        </p:nvSpPr>
+        <p:spPr/>
+      </p:sp>
+      <p:sp>
+        <p:nvSpPr>
+          <p:cNvPr id="3" name="Notes Placeholder 2"/>
+          <p:cNvSpPr>
             <a:spLocks noGrp="1"/>
           </p:cNvSpPr>
           <p:nvPr>
-            <p:ph type="sldImg" idx="2"/>
+            <p:ph type="body" sz="quarter" idx="3"/>
           </p:nvPr>
         </p:nvSpPr>
         <p:spPr/>
-      </p:sp>
-      <p:sp>
-        <p:nvSpPr>
-          <p:cNvPr id="3" name="Notes Placeholder 2"/>
+        <p:txBody>
+          <a:bodyPr/>
+          <a:lstStyle/>
+          <a:p>
+            <a:r>
+              <a:rPr dirty="0"/>
+              <a:t>This demonstrates MQE methodology on simulated data — next step would be real line validation.</a:t>
+            </a:r>
+          </a:p>
+        </p:txBody>
+      </p:sp>
+      <p:sp>
+        <p:nvSpPr>
+          <p:cNvPr id="4" name="Slide Number Placeholder 3"/>
           <p:cNvSpPr>
             <a:spLocks noGrp="1"/>
           </p:cNvSpPr>
           <p:nvPr>
-            <p:ph type="body" idx="3" sz="quarter"/>
-          </p:nvPr>
-        </p:nvSpPr>
-        <p:spPr/>
-        <p:txBody>
-          <a:bodyPr/>
-          <a:lstStyle/>
-          <a:p>
-            <a:r>
-              <a:t>Be honest about limits. This demonstrates MQE methodology on simulated data — next step would be real line validation.</a:t>
-            </a:r>
-          </a:p>
-        </p:txBody>
-      </p:sp>
-      <p:sp>
-        <p:nvSpPr>
-          <p:cNvPr id="4" name="Slide Number Placeholder 3"/>
-          <p:cNvSpPr>
-            <a:spLocks noGrp="1"/>
-          </p:cNvSpPr>
-          <p:nvPr>
-            <p:ph type="sldNum" idx="5" sz="quarter"/>
+            <p:ph type="sldNum" sz="quarter" idx="5"/>
           </p:nvPr>
         </p:nvSpPr>
         <p:spPr/>
@@ -1106,7 +906,7 @@
 </file>
 
 <file path=ppt/notesSlides/notesSlide18.xml><?xml version="1.0" encoding="utf-8"?>
-<p:notes xmlns:a="http://schemas.openxmlformats.org/drawingml/2006/main" xmlns:p="http://schemas.openxmlformats.org/presentationml/2006/main" xmlns:r="http://schemas.openxmlformats.org/officeDocument/2006/relationships">
+<p:notes xmlns:a="http://schemas.openxmlformats.org/drawingml/2006/main" xmlns:r="http://schemas.openxmlformats.org/officeDocument/2006/relationships" xmlns:p="http://schemas.openxmlformats.org/presentationml/2006/main">
   <p:cSld>
     <p:spTree>
       <p:nvGrpSpPr>
@@ -1126,43 +926,44 @@
         <p:nvSpPr>
           <p:cNvPr id="2" name="Slide Image Placeholder 1"/>
           <p:cNvSpPr>
+            <a:spLocks noGrp="1" noRot="1" noChangeAspect="1"/>
+          </p:cNvSpPr>
+          <p:nvPr>
+            <p:ph type="sldImg" idx="2"/>
+          </p:nvPr>
+        </p:nvSpPr>
+        <p:spPr/>
+      </p:sp>
+      <p:sp>
+        <p:nvSpPr>
+          <p:cNvPr id="3" name="Notes Placeholder 2"/>
+          <p:cNvSpPr>
             <a:spLocks noGrp="1"/>
           </p:cNvSpPr>
           <p:nvPr>
-            <p:ph type="sldImg" idx="2"/>
+            <p:ph type="body" sz="quarter" idx="3"/>
           </p:nvPr>
         </p:nvSpPr>
         <p:spPr/>
-      </p:sp>
-      <p:sp>
-        <p:nvSpPr>
-          <p:cNvPr id="3" name="Notes Placeholder 2"/>
+        <p:txBody>
+          <a:bodyPr/>
+          <a:lstStyle/>
+          <a:p>
+            <a:r>
+              <a:rPr dirty="0"/>
+              <a:t>I confirmed the defect, traced it to tool life and coolant, proved it with SPC and capability, and wrote containment plus preventive controls. All reproducible in Python, reviewable in JMP.</a:t>
+            </a:r>
+          </a:p>
+        </p:txBody>
+      </p:sp>
+      <p:sp>
+        <p:nvSpPr>
+          <p:cNvPr id="4" name="Slide Number Placeholder 3"/>
           <p:cNvSpPr>
             <a:spLocks noGrp="1"/>
           </p:cNvSpPr>
           <p:nvPr>
-            <p:ph type="body" idx="3" sz="quarter"/>
-          </p:nvPr>
-        </p:nvSpPr>
-        <p:spPr/>
-        <p:txBody>
-          <a:bodyPr/>
-          <a:lstStyle/>
-          <a:p>
-            <a:r>
-              <a:t>If I had 30 seconds: I confirmed the defect, traced it to tool life and coolant, proved it with SPC and capability, and wrote containment plus preventive controls. All reproducible in Python, reviewable in JMP.</a:t>
-            </a:r>
-          </a:p>
-        </p:txBody>
-      </p:sp>
-      <p:sp>
-        <p:nvSpPr>
-          <p:cNvPr id="4" name="Slide Number Placeholder 3"/>
-          <p:cNvSpPr>
-            <a:spLocks noGrp="1"/>
-          </p:cNvSpPr>
-          <p:nvPr>
-            <p:ph type="sldNum" idx="5" sz="quarter"/>
+            <p:ph type="sldNum" sz="quarter" idx="5"/>
           </p:nvPr>
         </p:nvSpPr>
         <p:spPr/>
@@ -1176,7 +977,7 @@
 </file>
 
 <file path=ppt/notesSlides/notesSlide19.xml><?xml version="1.0" encoding="utf-8"?>
-<p:notes xmlns:a="http://schemas.openxmlformats.org/drawingml/2006/main" xmlns:p="http://schemas.openxmlformats.org/presentationml/2006/main" xmlns:r="http://schemas.openxmlformats.org/officeDocument/2006/relationships">
+<p:notes xmlns:a="http://schemas.openxmlformats.org/drawingml/2006/main" xmlns:r="http://schemas.openxmlformats.org/officeDocument/2006/relationships" xmlns:p="http://schemas.openxmlformats.org/presentationml/2006/main">
   <p:cSld>
     <p:spTree>
       <p:nvGrpSpPr>
@@ -1196,43 +997,41 @@
         <p:nvSpPr>
           <p:cNvPr id="2" name="Slide Image Placeholder 1"/>
           <p:cNvSpPr>
+            <a:spLocks noGrp="1" noRot="1" noChangeAspect="1"/>
+          </p:cNvSpPr>
+          <p:nvPr>
+            <p:ph type="sldImg" idx="2"/>
+          </p:nvPr>
+        </p:nvSpPr>
+        <p:spPr/>
+      </p:sp>
+      <p:sp>
+        <p:nvSpPr>
+          <p:cNvPr id="3" name="Notes Placeholder 2"/>
+          <p:cNvSpPr>
             <a:spLocks noGrp="1"/>
           </p:cNvSpPr>
           <p:nvPr>
-            <p:ph type="sldImg" idx="2"/>
+            <p:ph type="body" sz="quarter" idx="3"/>
           </p:nvPr>
         </p:nvSpPr>
         <p:spPr/>
-      </p:sp>
-      <p:sp>
-        <p:nvSpPr>
-          <p:cNvPr id="3" name="Notes Placeholder 2"/>
+        <p:txBody>
+          <a:bodyPr/>
+          <a:lstStyle/>
+          <a:p>
+            <a:endParaRPr dirty="0"/>
+          </a:p>
+        </p:txBody>
+      </p:sp>
+      <p:sp>
+        <p:nvSpPr>
+          <p:cNvPr id="4" name="Slide Number Placeholder 3"/>
           <p:cNvSpPr>
             <a:spLocks noGrp="1"/>
           </p:cNvSpPr>
           <p:nvPr>
-            <p:ph type="body" idx="3" sz="quarter"/>
-          </p:nvPr>
-        </p:nvSpPr>
-        <p:spPr/>
-        <p:txBody>
-          <a:bodyPr/>
-          <a:lstStyle/>
-          <a:p>
-            <a:r>
-              <a:t>Pause for questions. Point them to the GitHub repo if they want to dig into the code.</a:t>
-            </a:r>
-          </a:p>
-        </p:txBody>
-      </p:sp>
-      <p:sp>
-        <p:nvSpPr>
-          <p:cNvPr id="4" name="Slide Number Placeholder 3"/>
-          <p:cNvSpPr>
-            <a:spLocks noGrp="1"/>
-          </p:cNvSpPr>
-          <p:nvPr>
-            <p:ph type="sldNum" idx="5" sz="quarter"/>
+            <p:ph type="sldNum" sz="quarter" idx="5"/>
           </p:nvPr>
         </p:nvSpPr>
         <p:spPr/>
@@ -1246,7 +1045,7 @@
 </file>
 
 <file path=ppt/notesSlides/notesSlide2.xml><?xml version="1.0" encoding="utf-8"?>
-<p:notes xmlns:a="http://schemas.openxmlformats.org/drawingml/2006/main" xmlns:p="http://schemas.openxmlformats.org/presentationml/2006/main" xmlns:r="http://schemas.openxmlformats.org/officeDocument/2006/relationships">
+<p:notes xmlns:a="http://schemas.openxmlformats.org/drawingml/2006/main" xmlns:r="http://schemas.openxmlformats.org/officeDocument/2006/relationships" xmlns:p="http://schemas.openxmlformats.org/presentationml/2006/main">
   <p:cSld>
     <p:spTree>
       <p:nvGrpSpPr>
@@ -1266,43 +1065,44 @@
         <p:nvSpPr>
           <p:cNvPr id="2" name="Slide Image Placeholder 1"/>
           <p:cNvSpPr>
+            <a:spLocks noGrp="1" noRot="1" noChangeAspect="1"/>
+          </p:cNvSpPr>
+          <p:nvPr>
+            <p:ph type="sldImg" idx="2"/>
+          </p:nvPr>
+        </p:nvSpPr>
+        <p:spPr/>
+      </p:sp>
+      <p:sp>
+        <p:nvSpPr>
+          <p:cNvPr id="3" name="Notes Placeholder 2"/>
+          <p:cNvSpPr>
             <a:spLocks noGrp="1"/>
           </p:cNvSpPr>
           <p:nvPr>
-            <p:ph type="sldImg" idx="2"/>
+            <p:ph type="body" sz="quarter" idx="3"/>
           </p:nvPr>
         </p:nvSpPr>
         <p:spPr/>
-      </p:sp>
-      <p:sp>
-        <p:nvSpPr>
-          <p:cNvPr id="3" name="Notes Placeholder 2"/>
+        <p:txBody>
+          <a:bodyPr/>
+          <a:lstStyle/>
+          <a:p>
+            <a:r>
+              <a:rPr lang="en-US" dirty="0"/>
+              <a:t>Start with the business problem — yield dropped after CNC contouring. My job as MQE is to localize the issue and recommend containment and fixes.</a:t>
+            </a:r>
+          </a:p>
+        </p:txBody>
+      </p:sp>
+      <p:sp>
+        <p:nvSpPr>
+          <p:cNvPr id="4" name="Slide Number Placeholder 3"/>
           <p:cNvSpPr>
             <a:spLocks noGrp="1"/>
           </p:cNvSpPr>
           <p:nvPr>
-            <p:ph type="body" idx="3" sz="quarter"/>
-          </p:nvPr>
-        </p:nvSpPr>
-        <p:spPr/>
-        <p:txBody>
-          <a:bodyPr/>
-          <a:lstStyle/>
-          <a:p>
-            <a:r>
-              <a:t>Start with the business problem — yield dropped after CNC contouring. My job as MQE is to localize the issue and recommend containment and fixes.</a:t>
-            </a:r>
-          </a:p>
-        </p:txBody>
-      </p:sp>
-      <p:sp>
-        <p:nvSpPr>
-          <p:cNvPr id="4" name="Slide Number Placeholder 3"/>
-          <p:cNvSpPr>
-            <a:spLocks noGrp="1"/>
-          </p:cNvSpPr>
-          <p:nvPr>
-            <p:ph type="sldNum" idx="5" sz="quarter"/>
+            <p:ph type="sldNum" sz="quarter" idx="5"/>
           </p:nvPr>
         </p:nvSpPr>
         <p:spPr/>
@@ -1316,7 +1116,7 @@
 </file>
 
 <file path=ppt/notesSlides/notesSlide3.xml><?xml version="1.0" encoding="utf-8"?>
-<p:notes xmlns:a="http://schemas.openxmlformats.org/drawingml/2006/main" xmlns:p="http://schemas.openxmlformats.org/presentationml/2006/main" xmlns:r="http://schemas.openxmlformats.org/officeDocument/2006/relationships">
+<p:notes xmlns:a="http://schemas.openxmlformats.org/drawingml/2006/main" xmlns:r="http://schemas.openxmlformats.org/officeDocument/2006/relationships" xmlns:p="http://schemas.openxmlformats.org/presentationml/2006/main">
   <p:cSld>
     <p:spTree>
       <p:nvGrpSpPr>
@@ -1336,43 +1136,45 @@
         <p:nvSpPr>
           <p:cNvPr id="2" name="Slide Image Placeholder 1"/>
           <p:cNvSpPr>
+            <a:spLocks noGrp="1" noRot="1" noChangeAspect="1"/>
+          </p:cNvSpPr>
+          <p:nvPr>
+            <p:ph type="sldImg" idx="2"/>
+          </p:nvPr>
+        </p:nvSpPr>
+        <p:spPr/>
+      </p:sp>
+      <p:sp>
+        <p:nvSpPr>
+          <p:cNvPr id="3" name="Notes Placeholder 2"/>
+          <p:cNvSpPr>
             <a:spLocks noGrp="1"/>
           </p:cNvSpPr>
           <p:nvPr>
-            <p:ph type="sldImg" idx="2"/>
+            <p:ph type="body" sz="quarter" idx="3"/>
           </p:nvPr>
         </p:nvSpPr>
         <p:spPr/>
-      </p:sp>
-      <p:sp>
-        <p:nvSpPr>
-          <p:cNvPr id="3" name="Notes Placeholder 2"/>
+        <p:txBody>
+          <a:bodyPr/>
+          <a:lstStyle/>
+          <a:p>
+            <a:r>
+              <a:rPr lang="en-US"/>
+              <a:t>I'm not trying to solve every defect mode in v1. Edge chipping is the dominant signature, so that's where I focused.</a:t>
+            </a:r>
+            <a:endParaRPr lang="en-US" dirty="0"/>
+          </a:p>
+        </p:txBody>
+      </p:sp>
+      <p:sp>
+        <p:nvSpPr>
+          <p:cNvPr id="4" name="Slide Number Placeholder 3"/>
           <p:cNvSpPr>
             <a:spLocks noGrp="1"/>
           </p:cNvSpPr>
           <p:nvPr>
-            <p:ph type="body" idx="3" sz="quarter"/>
-          </p:nvPr>
-        </p:nvSpPr>
-        <p:spPr/>
-        <p:txBody>
-          <a:bodyPr/>
-          <a:lstStyle/>
-          <a:p>
-            <a:r>
-              <a:t>I'm not trying to solve every defect mode in v1. Edge chipping is the dominant signature, so that's where I focused.</a:t>
-            </a:r>
-          </a:p>
-        </p:txBody>
-      </p:sp>
-      <p:sp>
-        <p:nvSpPr>
-          <p:cNvPr id="4" name="Slide Number Placeholder 3"/>
-          <p:cNvSpPr>
-            <a:spLocks noGrp="1"/>
-          </p:cNvSpPr>
-          <p:nvPr>
-            <p:ph type="sldNum" idx="5" sz="quarter"/>
+            <p:ph type="sldNum" sz="quarter" idx="5"/>
           </p:nvPr>
         </p:nvSpPr>
         <p:spPr/>
@@ -1386,7 +1188,7 @@
 </file>
 
 <file path=ppt/notesSlides/notesSlide4.xml><?xml version="1.0" encoding="utf-8"?>
-<p:notes xmlns:a="http://schemas.openxmlformats.org/drawingml/2006/main" xmlns:p="http://schemas.openxmlformats.org/presentationml/2006/main" xmlns:r="http://schemas.openxmlformats.org/officeDocument/2006/relationships">
+<p:notes xmlns:a="http://schemas.openxmlformats.org/drawingml/2006/main" xmlns:r="http://schemas.openxmlformats.org/officeDocument/2006/relationships" xmlns:p="http://schemas.openxmlformats.org/presentationml/2006/main">
   <p:cSld>
     <p:spTree>
       <p:nvGrpSpPr>
@@ -1406,43 +1208,45 @@
         <p:nvSpPr>
           <p:cNvPr id="2" name="Slide Image Placeholder 1"/>
           <p:cNvSpPr>
+            <a:spLocks noGrp="1" noRot="1" noChangeAspect="1"/>
+          </p:cNvSpPr>
+          <p:nvPr>
+            <p:ph type="sldImg" idx="2"/>
+          </p:nvPr>
+        </p:nvSpPr>
+        <p:spPr/>
+      </p:sp>
+      <p:sp>
+        <p:nvSpPr>
+          <p:cNvPr id="3" name="Notes Placeholder 2"/>
+          <p:cNvSpPr>
             <a:spLocks noGrp="1"/>
           </p:cNvSpPr>
           <p:nvPr>
-            <p:ph type="sldImg" idx="2"/>
+            <p:ph type="body" sz="quarter" idx="3"/>
           </p:nvPr>
         </p:nvSpPr>
         <p:spPr/>
-      </p:sp>
-      <p:sp>
-        <p:nvSpPr>
-          <p:cNvPr id="3" name="Notes Placeholder 2"/>
+        <p:txBody>
+          <a:bodyPr/>
+          <a:lstStyle/>
+          <a:p>
+            <a:r>
+              <a:rPr lang="en-US"/>
+              <a:t>I designed the dataset to mirror real traceability fields. There's a planted interaction — high tool life plus unstable coolant — so I can show whether analysis finds it without cheating.</a:t>
+            </a:r>
+            <a:endParaRPr lang="en-US" dirty="0"/>
+          </a:p>
+        </p:txBody>
+      </p:sp>
+      <p:sp>
+        <p:nvSpPr>
+          <p:cNvPr id="4" name="Slide Number Placeholder 3"/>
           <p:cNvSpPr>
             <a:spLocks noGrp="1"/>
           </p:cNvSpPr>
           <p:nvPr>
-            <p:ph type="body" idx="3" sz="quarter"/>
-          </p:nvPr>
-        </p:nvSpPr>
-        <p:spPr/>
-        <p:txBody>
-          <a:bodyPr/>
-          <a:lstStyle/>
-          <a:p>
-            <a:r>
-              <a:t>I designed the dataset to mirror real traceability fields. There's a planted interaction — high tool life plus unstable coolant — so I can show whether analysis finds it without cheating.</a:t>
-            </a:r>
-          </a:p>
-        </p:txBody>
-      </p:sp>
-      <p:sp>
-        <p:nvSpPr>
-          <p:cNvPr id="4" name="Slide Number Placeholder 3"/>
-          <p:cNvSpPr>
-            <a:spLocks noGrp="1"/>
-          </p:cNvSpPr>
-          <p:nvPr>
-            <p:ph type="sldNum" idx="5" sz="quarter"/>
+            <p:ph type="sldNum" sz="quarter" idx="5"/>
           </p:nvPr>
         </p:nvSpPr>
         <p:spPr/>
@@ -1456,7 +1260,7 @@
 </file>
 
 <file path=ppt/notesSlides/notesSlide5.xml><?xml version="1.0" encoding="utf-8"?>
-<p:notes xmlns:a="http://schemas.openxmlformats.org/drawingml/2006/main" xmlns:p="http://schemas.openxmlformats.org/presentationml/2006/main" xmlns:r="http://schemas.openxmlformats.org/officeDocument/2006/relationships">
+<p:notes xmlns:a="http://schemas.openxmlformats.org/drawingml/2006/main" xmlns:r="http://schemas.openxmlformats.org/officeDocument/2006/relationships" xmlns:p="http://schemas.openxmlformats.org/presentationml/2006/main">
   <p:cSld>
     <p:spTree>
       <p:nvGrpSpPr>
@@ -1476,43 +1280,44 @@
         <p:nvSpPr>
           <p:cNvPr id="2" name="Slide Image Placeholder 1"/>
           <p:cNvSpPr>
+            <a:spLocks noGrp="1" noRot="1" noChangeAspect="1"/>
+          </p:cNvSpPr>
+          <p:nvPr>
+            <p:ph type="sldImg" idx="2"/>
+          </p:nvPr>
+        </p:nvSpPr>
+        <p:spPr/>
+      </p:sp>
+      <p:sp>
+        <p:nvSpPr>
+          <p:cNvPr id="3" name="Notes Placeholder 2"/>
+          <p:cNvSpPr>
             <a:spLocks noGrp="1"/>
           </p:cNvSpPr>
           <p:nvPr>
-            <p:ph type="sldImg" idx="2"/>
+            <p:ph type="body" sz="quarter" idx="3"/>
           </p:nvPr>
         </p:nvSpPr>
         <p:spPr/>
-      </p:sp>
-      <p:sp>
-        <p:nvSpPr>
-          <p:cNvPr id="3" name="Notes Placeholder 2"/>
+        <p:txBody>
+          <a:bodyPr/>
+          <a:lstStyle/>
+          <a:p>
+            <a:r>
+              <a:rPr dirty="0"/>
+              <a:t>Python runs the reproducible pipeline. JMP is for live filtering and visual confirmation in a cross-functional review.</a:t>
+            </a:r>
+          </a:p>
+        </p:txBody>
+      </p:sp>
+      <p:sp>
+        <p:nvSpPr>
+          <p:cNvPr id="4" name="Slide Number Placeholder 3"/>
           <p:cNvSpPr>
             <a:spLocks noGrp="1"/>
           </p:cNvSpPr>
           <p:nvPr>
-            <p:ph type="body" idx="3" sz="quarter"/>
-          </p:nvPr>
-        </p:nvSpPr>
-        <p:spPr/>
-        <p:txBody>
-          <a:bodyPr/>
-          <a:lstStyle/>
-          <a:p>
-            <a:r>
-              <a:t>Python runs the reproducible pipeline. JMP is for live filtering and visual confirmation in a cross-functional review.</a:t>
-            </a:r>
-          </a:p>
-        </p:txBody>
-      </p:sp>
-      <p:sp>
-        <p:nvSpPr>
-          <p:cNvPr id="4" name="Slide Number Placeholder 3"/>
-          <p:cNvSpPr>
-            <a:spLocks noGrp="1"/>
-          </p:cNvSpPr>
-          <p:nvPr>
-            <p:ph type="sldNum" idx="5" sz="quarter"/>
+            <p:ph type="sldNum" sz="quarter" idx="5"/>
           </p:nvPr>
         </p:nvSpPr>
         <p:spPr/>
@@ -1526,7 +1331,7 @@
 </file>
 
 <file path=ppt/notesSlides/notesSlide6.xml><?xml version="1.0" encoding="utf-8"?>
-<p:notes xmlns:a="http://schemas.openxmlformats.org/drawingml/2006/main" xmlns:p="http://schemas.openxmlformats.org/presentationml/2006/main" xmlns:r="http://schemas.openxmlformats.org/officeDocument/2006/relationships">
+<p:notes xmlns:a="http://schemas.openxmlformats.org/drawingml/2006/main" xmlns:r="http://schemas.openxmlformats.org/officeDocument/2006/relationships" xmlns:p="http://schemas.openxmlformats.org/presentationml/2006/main">
   <p:cSld>
     <p:spTree>
       <p:nvGrpSpPr>
@@ -1546,43 +1351,41 @@
         <p:nvSpPr>
           <p:cNvPr id="2" name="Slide Image Placeholder 1"/>
           <p:cNvSpPr>
+            <a:spLocks noGrp="1" noRot="1" noChangeAspect="1"/>
+          </p:cNvSpPr>
+          <p:nvPr>
+            <p:ph type="sldImg" idx="2"/>
+          </p:nvPr>
+        </p:nvSpPr>
+        <p:spPr/>
+      </p:sp>
+      <p:sp>
+        <p:nvSpPr>
+          <p:cNvPr id="3" name="Notes Placeholder 2"/>
+          <p:cNvSpPr>
             <a:spLocks noGrp="1"/>
           </p:cNvSpPr>
           <p:nvPr>
-            <p:ph type="sldImg" idx="2"/>
+            <p:ph type="body" sz="quarter" idx="3"/>
           </p:nvPr>
         </p:nvSpPr>
         <p:spPr/>
-      </p:sp>
-      <p:sp>
-        <p:nvSpPr>
-          <p:cNvPr id="3" name="Notes Placeholder 2"/>
+        <p:txBody>
+          <a:bodyPr/>
+          <a:lstStyle/>
+          <a:p>
+            <a:endParaRPr dirty="0"/>
+          </a:p>
+        </p:txBody>
+      </p:sp>
+      <p:sp>
+        <p:nvSpPr>
+          <p:cNvPr id="4" name="Slide Number Placeholder 3"/>
           <p:cNvSpPr>
             <a:spLocks noGrp="1"/>
           </p:cNvSpPr>
           <p:nvPr>
-            <p:ph type="body" idx="3" sz="quarter"/>
-          </p:nvPr>
-        </p:nvSpPr>
-        <p:spPr/>
-        <p:txBody>
-          <a:bodyPr/>
-          <a:lstStyle/>
-          <a:p>
-            <a:r>
-              <a:t>If they ask 'did you actually build this?' — yes. Here's the repo structure, the raw CSV, and the scripts that regenerate every chart.</a:t>
-            </a:r>
-          </a:p>
-        </p:txBody>
-      </p:sp>
-      <p:sp>
-        <p:nvSpPr>
-          <p:cNvPr id="4" name="Slide Number Placeholder 3"/>
-          <p:cNvSpPr>
-            <a:spLocks noGrp="1"/>
-          </p:cNvSpPr>
-          <p:nvPr>
-            <p:ph type="sldNum" idx="5" sz="quarter"/>
+            <p:ph type="sldNum" sz="quarter" idx="5"/>
           </p:nvPr>
         </p:nvSpPr>
         <p:spPr/>
@@ -1596,7 +1399,7 @@
 </file>
 
 <file path=ppt/notesSlides/notesSlide7.xml><?xml version="1.0" encoding="utf-8"?>
-<p:notes xmlns:a="http://schemas.openxmlformats.org/drawingml/2006/main" xmlns:p="http://schemas.openxmlformats.org/presentationml/2006/main" xmlns:r="http://schemas.openxmlformats.org/officeDocument/2006/relationships">
+<p:notes xmlns:a="http://schemas.openxmlformats.org/drawingml/2006/main" xmlns:r="http://schemas.openxmlformats.org/officeDocument/2006/relationships" xmlns:p="http://schemas.openxmlformats.org/presentationml/2006/main">
   <p:cSld>
     <p:spTree>
       <p:nvGrpSpPr>
@@ -1616,43 +1419,43 @@
         <p:nvSpPr>
           <p:cNvPr id="2" name="Slide Image Placeholder 1"/>
           <p:cNvSpPr>
+            <a:spLocks noGrp="1" noRot="1" noChangeAspect="1"/>
+          </p:cNvSpPr>
+          <p:nvPr>
+            <p:ph type="sldImg" idx="2"/>
+          </p:nvPr>
+        </p:nvSpPr>
+        <p:spPr/>
+      </p:sp>
+      <p:sp>
+        <p:nvSpPr>
+          <p:cNvPr id="3" name="Notes Placeholder 2"/>
+          <p:cNvSpPr>
             <a:spLocks noGrp="1"/>
           </p:cNvSpPr>
           <p:nvPr>
-            <p:ph type="sldImg" idx="2"/>
+            <p:ph type="body" sz="quarter" idx="3"/>
           </p:nvPr>
         </p:nvSpPr>
         <p:spPr/>
-      </p:sp>
-      <p:sp>
-        <p:nvSpPr>
-          <p:cNvPr id="3" name="Notes Placeholder 2"/>
+        <p:txBody>
+          <a:bodyPr/>
+          <a:lstStyle/>
+          <a:p>
+            <a:r>
+              <a:t>I used AI to speed up coding and documentation. But I manually checked stats assumptions, ML leakage rules, and every MQE conclusion. Don't oversell AI — it's an accelerator, not the engineer.</a:t>
+            </a:r>
+          </a:p>
+        </p:txBody>
+      </p:sp>
+      <p:sp>
+        <p:nvSpPr>
+          <p:cNvPr id="4" name="Slide Number Placeholder 3"/>
           <p:cNvSpPr>
             <a:spLocks noGrp="1"/>
           </p:cNvSpPr>
           <p:nvPr>
-            <p:ph type="body" idx="3" sz="quarter"/>
-          </p:nvPr>
-        </p:nvSpPr>
-        <p:spPr/>
-        <p:txBody>
-          <a:bodyPr/>
-          <a:lstStyle/>
-          <a:p>
-            <a:r>
-              <a:t>I used AI to speed up coding and documentation. But I manually checked stats assumptions, ML leakage rules, and every MQE conclusion. Don't oversell AI — it's an accelerator, not the engineer.</a:t>
-            </a:r>
-          </a:p>
-        </p:txBody>
-      </p:sp>
-      <p:sp>
-        <p:nvSpPr>
-          <p:cNvPr id="4" name="Slide Number Placeholder 3"/>
-          <p:cNvSpPr>
-            <a:spLocks noGrp="1"/>
-          </p:cNvSpPr>
-          <p:nvPr>
-            <p:ph type="sldNum" idx="5" sz="quarter"/>
+            <p:ph type="sldNum" sz="quarter" idx="5"/>
           </p:nvPr>
         </p:nvSpPr>
         <p:spPr/>
@@ -1666,7 +1469,7 @@
 </file>
 
 <file path=ppt/notesSlides/notesSlide8.xml><?xml version="1.0" encoding="utf-8"?>
-<p:notes xmlns:a="http://schemas.openxmlformats.org/drawingml/2006/main" xmlns:p="http://schemas.openxmlformats.org/presentationml/2006/main" xmlns:r="http://schemas.openxmlformats.org/officeDocument/2006/relationships">
+<p:notes xmlns:a="http://schemas.openxmlformats.org/drawingml/2006/main" xmlns:r="http://schemas.openxmlformats.org/officeDocument/2006/relationships" xmlns:p="http://schemas.openxmlformats.org/presentationml/2006/main">
   <p:cSld>
     <p:spTree>
       <p:nvGrpSpPr>
@@ -1686,43 +1489,43 @@
         <p:nvSpPr>
           <p:cNvPr id="2" name="Slide Image Placeholder 1"/>
           <p:cNvSpPr>
+            <a:spLocks noGrp="1" noRot="1" noChangeAspect="1"/>
+          </p:cNvSpPr>
+          <p:nvPr>
+            <p:ph type="sldImg" idx="2"/>
+          </p:nvPr>
+        </p:nvSpPr>
+        <p:spPr/>
+      </p:sp>
+      <p:sp>
+        <p:nvSpPr>
+          <p:cNvPr id="3" name="Notes Placeholder 2"/>
+          <p:cNvSpPr>
             <a:spLocks noGrp="1"/>
           </p:cNvSpPr>
           <p:nvPr>
-            <p:ph type="sldImg" idx="2"/>
+            <p:ph type="body" sz="quarter" idx="3"/>
           </p:nvPr>
         </p:nvSpPr>
         <p:spPr/>
-      </p:sp>
-      <p:sp>
-        <p:nvSpPr>
-          <p:cNvPr id="3" name="Notes Placeholder 2"/>
+        <p:txBody>
+          <a:bodyPr/>
+          <a:lstStyle/>
+          <a:p>
+            <a:r>
+              <a:t>First step in any excursion: confirm the defect signature. Three-point-eight-five percent NG, and edge chipping is ~81% of that. That's my Phase 1 scope.</a:t>
+            </a:r>
+          </a:p>
+        </p:txBody>
+      </p:sp>
+      <p:sp>
+        <p:nvSpPr>
+          <p:cNvPr id="4" name="Slide Number Placeholder 3"/>
           <p:cNvSpPr>
             <a:spLocks noGrp="1"/>
           </p:cNvSpPr>
           <p:nvPr>
-            <p:ph type="body" idx="3" sz="quarter"/>
-          </p:nvPr>
-        </p:nvSpPr>
-        <p:spPr/>
-        <p:txBody>
-          <a:bodyPr/>
-          <a:lstStyle/>
-          <a:p>
-            <a:r>
-              <a:t>First step in any excursion: confirm the defect signature. Three-point-eight-five percent NG, and edge chipping is ~81% of that. That's my Phase 1 scope.</a:t>
-            </a:r>
-          </a:p>
-        </p:txBody>
-      </p:sp>
-      <p:sp>
-        <p:nvSpPr>
-          <p:cNvPr id="4" name="Slide Number Placeholder 3"/>
-          <p:cNvSpPr>
-            <a:spLocks noGrp="1"/>
-          </p:cNvSpPr>
-          <p:nvPr>
-            <p:ph type="sldNum" idx="5" sz="quarter"/>
+            <p:ph type="sldNum" sz="quarter" idx="5"/>
           </p:nvPr>
         </p:nvSpPr>
         <p:spPr/>
@@ -1736,7 +1539,7 @@
 </file>
 
 <file path=ppt/notesSlides/notesSlide9.xml><?xml version="1.0" encoding="utf-8"?>
-<p:notes xmlns:a="http://schemas.openxmlformats.org/drawingml/2006/main" xmlns:p="http://schemas.openxmlformats.org/presentationml/2006/main" xmlns:r="http://schemas.openxmlformats.org/officeDocument/2006/relationships">
+<p:notes xmlns:a="http://schemas.openxmlformats.org/drawingml/2006/main" xmlns:r="http://schemas.openxmlformats.org/officeDocument/2006/relationships" xmlns:p="http://schemas.openxmlformats.org/presentationml/2006/main">
   <p:cSld>
     <p:spTree>
       <p:nvGrpSpPr>
@@ -1756,43 +1559,43 @@
         <p:nvSpPr>
           <p:cNvPr id="2" name="Slide Image Placeholder 1"/>
           <p:cNvSpPr>
+            <a:spLocks noGrp="1" noRot="1" noChangeAspect="1"/>
+          </p:cNvSpPr>
+          <p:nvPr>
+            <p:ph type="sldImg" idx="2"/>
+          </p:nvPr>
+        </p:nvSpPr>
+        <p:spPr/>
+      </p:sp>
+      <p:sp>
+        <p:nvSpPr>
+          <p:cNvPr id="3" name="Notes Placeholder 2"/>
+          <p:cNvSpPr>
             <a:spLocks noGrp="1"/>
           </p:cNvSpPr>
           <p:nvPr>
-            <p:ph type="sldImg" idx="2"/>
+            <p:ph type="body" sz="quarter" idx="3"/>
           </p:nvPr>
         </p:nvSpPr>
         <p:spPr/>
-      </p:sp>
-      <p:sp>
-        <p:nvSpPr>
-          <p:cNvPr id="3" name="Notes Placeholder 2"/>
+        <p:txBody>
+          <a:bodyPr/>
+          <a:lstStyle/>
+          <a:p>
+            <a:r>
+              <a:t>This is classic traceability work — stratify before you jump to a root cause. A few machines and fixtures light up; that's where I drill deeper.</a:t>
+            </a:r>
+          </a:p>
+        </p:txBody>
+      </p:sp>
+      <p:sp>
+        <p:nvSpPr>
+          <p:cNvPr id="4" name="Slide Number Placeholder 3"/>
           <p:cNvSpPr>
             <a:spLocks noGrp="1"/>
           </p:cNvSpPr>
           <p:nvPr>
-            <p:ph type="body" idx="3" sz="quarter"/>
-          </p:nvPr>
-        </p:nvSpPr>
-        <p:spPr/>
-        <p:txBody>
-          <a:bodyPr/>
-          <a:lstStyle/>
-          <a:p>
-            <a:r>
-              <a:t>This is classic traceability work — stratify before you jump to a root cause. A few machines and fixtures light up; that's where I drill deeper.</a:t>
-            </a:r>
-          </a:p>
-        </p:txBody>
-      </p:sp>
-      <p:sp>
-        <p:nvSpPr>
-          <p:cNvPr id="4" name="Slide Number Placeholder 3"/>
-          <p:cNvSpPr>
-            <a:spLocks noGrp="1"/>
-          </p:cNvSpPr>
-          <p:nvPr>
-            <p:ph type="sldNum" idx="5" sz="quarter"/>
+            <p:ph type="sldNum" sz="quarter" idx="5"/>
           </p:nvPr>
         </p:nvSpPr>
         <p:spPr/>
@@ -1843,10 +1646,9 @@
           <a:lstStyle/>
           <a:p>
             <a:r>
-              <a:rPr lang="en-US" smtClean="0"/>
+              <a:rPr lang="en-US"/>
               <a:t>Click to edit Master title style</a:t>
             </a:r>
-            <a:endParaRPr lang="en-US"/>
           </a:p>
         </p:txBody>
       </p:sp>
@@ -1962,10 +1764,9 @@
           </a:lstStyle>
           <a:p>
             <a:r>
-              <a:rPr lang="en-US" smtClean="0"/>
+              <a:rPr lang="en-US"/>
               <a:t>Click to edit Master subtitle style</a:t>
             </a:r>
-            <a:endParaRPr lang="en-US"/>
           </a:p>
         </p:txBody>
       </p:sp>
@@ -1986,7 +1787,7 @@
           <a:p>
             <a:fld id="{5BCAD085-E8A6-8845-BD4E-CB4CCA059FC4}" type="datetimeFigureOut">
               <a:rPr lang="en-US" smtClean="0"/>
-              <a:t>1/27/13</a:t>
+              <a:t>5/25/2026</a:t>
             </a:fld>
             <a:endParaRPr lang="en-US"/>
           </a:p>
@@ -2080,10 +1881,9 @@
           <a:lstStyle/>
           <a:p>
             <a:r>
-              <a:rPr lang="en-US" smtClean="0"/>
+              <a:rPr lang="en-US"/>
               <a:t>Click to edit Master title style</a:t>
             </a:r>
-            <a:endParaRPr lang="en-US"/>
           </a:p>
         </p:txBody>
       </p:sp>
@@ -2104,38 +1904,37 @@
           <a:p>
             <a:pPr lvl="0"/>
             <a:r>
-              <a:rPr lang="en-US" smtClean="0"/>
+              <a:rPr lang="en-US"/>
               <a:t>Click to edit Master text styles</a:t>
             </a:r>
           </a:p>
           <a:p>
             <a:pPr lvl="1"/>
             <a:r>
-              <a:rPr lang="en-US" smtClean="0"/>
+              <a:rPr lang="en-US"/>
               <a:t>Second level</a:t>
             </a:r>
           </a:p>
           <a:p>
             <a:pPr lvl="2"/>
             <a:r>
-              <a:rPr lang="en-US" smtClean="0"/>
+              <a:rPr lang="en-US"/>
               <a:t>Third level</a:t>
             </a:r>
           </a:p>
           <a:p>
             <a:pPr lvl="3"/>
             <a:r>
-              <a:rPr lang="en-US" smtClean="0"/>
+              <a:rPr lang="en-US"/>
               <a:t>Fourth level</a:t>
             </a:r>
           </a:p>
           <a:p>
             <a:pPr lvl="4"/>
             <a:r>
-              <a:rPr lang="en-US" smtClean="0"/>
+              <a:rPr lang="en-US"/>
               <a:t>Fifth level</a:t>
             </a:r>
-            <a:endParaRPr lang="en-US"/>
           </a:p>
         </p:txBody>
       </p:sp>
@@ -2156,7 +1955,7 @@
           <a:p>
             <a:fld id="{5BCAD085-E8A6-8845-BD4E-CB4CCA059FC4}" type="datetimeFigureOut">
               <a:rPr lang="en-US" smtClean="0"/>
-              <a:t>1/27/13</a:t>
+              <a:t>5/25/2026</a:t>
             </a:fld>
             <a:endParaRPr lang="en-US"/>
           </a:p>
@@ -2255,10 +2054,9 @@
           <a:lstStyle/>
           <a:p>
             <a:r>
-              <a:rPr lang="en-US" smtClean="0"/>
+              <a:rPr lang="en-US"/>
               <a:t>Click to edit Master title style</a:t>
             </a:r>
-            <a:endParaRPr lang="en-US"/>
           </a:p>
         </p:txBody>
       </p:sp>
@@ -2284,38 +2082,37 @@
           <a:p>
             <a:pPr lvl="0"/>
             <a:r>
-              <a:rPr lang="en-US" smtClean="0"/>
+              <a:rPr lang="en-US"/>
               <a:t>Click to edit Master text styles</a:t>
             </a:r>
           </a:p>
           <a:p>
             <a:pPr lvl="1"/>
             <a:r>
-              <a:rPr lang="en-US" smtClean="0"/>
+              <a:rPr lang="en-US"/>
               <a:t>Second level</a:t>
             </a:r>
           </a:p>
           <a:p>
             <a:pPr lvl="2"/>
             <a:r>
-              <a:rPr lang="en-US" smtClean="0"/>
+              <a:rPr lang="en-US"/>
               <a:t>Third level</a:t>
             </a:r>
           </a:p>
           <a:p>
             <a:pPr lvl="3"/>
             <a:r>
-              <a:rPr lang="en-US" smtClean="0"/>
+              <a:rPr lang="en-US"/>
               <a:t>Fourth level</a:t>
             </a:r>
           </a:p>
           <a:p>
             <a:pPr lvl="4"/>
             <a:r>
-              <a:rPr lang="en-US" smtClean="0"/>
+              <a:rPr lang="en-US"/>
               <a:t>Fifth level</a:t>
             </a:r>
-            <a:endParaRPr lang="en-US"/>
           </a:p>
         </p:txBody>
       </p:sp>
@@ -2336,7 +2133,7 @@
           <a:p>
             <a:fld id="{5BCAD085-E8A6-8845-BD4E-CB4CCA059FC4}" type="datetimeFigureOut">
               <a:rPr lang="en-US" smtClean="0"/>
-              <a:t>1/27/13</a:t>
+              <a:t>5/25/2026</a:t>
             </a:fld>
             <a:endParaRPr lang="en-US"/>
           </a:p>
@@ -2430,10 +2227,9 @@
           <a:lstStyle/>
           <a:p>
             <a:r>
-              <a:rPr lang="en-US" smtClean="0"/>
+              <a:rPr lang="en-US"/>
               <a:t>Click to edit Master title style</a:t>
             </a:r>
-            <a:endParaRPr lang="en-US"/>
           </a:p>
         </p:txBody>
       </p:sp>
@@ -2454,38 +2250,37 @@
           <a:p>
             <a:pPr lvl="0"/>
             <a:r>
-              <a:rPr lang="en-US" smtClean="0"/>
+              <a:rPr lang="en-US"/>
               <a:t>Click to edit Master text styles</a:t>
             </a:r>
           </a:p>
           <a:p>
             <a:pPr lvl="1"/>
             <a:r>
-              <a:rPr lang="en-US" smtClean="0"/>
+              <a:rPr lang="en-US"/>
               <a:t>Second level</a:t>
             </a:r>
           </a:p>
           <a:p>
             <a:pPr lvl="2"/>
             <a:r>
-              <a:rPr lang="en-US" smtClean="0"/>
+              <a:rPr lang="en-US"/>
               <a:t>Third level</a:t>
             </a:r>
           </a:p>
           <a:p>
             <a:pPr lvl="3"/>
             <a:r>
-              <a:rPr lang="en-US" smtClean="0"/>
+              <a:rPr lang="en-US"/>
               <a:t>Fourth level</a:t>
             </a:r>
           </a:p>
           <a:p>
             <a:pPr lvl="4"/>
             <a:r>
-              <a:rPr lang="en-US" smtClean="0"/>
+              <a:rPr lang="en-US"/>
               <a:t>Fifth level</a:t>
             </a:r>
-            <a:endParaRPr lang="en-US"/>
           </a:p>
         </p:txBody>
       </p:sp>
@@ -2506,7 +2301,7 @@
           <a:p>
             <a:fld id="{5BCAD085-E8A6-8845-BD4E-CB4CCA059FC4}" type="datetimeFigureOut">
               <a:rPr lang="en-US" smtClean="0"/>
-              <a:t>1/27/13</a:t>
+              <a:t>5/25/2026</a:t>
             </a:fld>
             <a:endParaRPr lang="en-US"/>
           </a:p>
@@ -2609,10 +2404,9 @@
           </a:lstStyle>
           <a:p>
             <a:r>
-              <a:rPr lang="en-US" smtClean="0"/>
+              <a:rPr lang="en-US"/>
               <a:t>Click to edit Master title style</a:t>
             </a:r>
-            <a:endParaRPr lang="en-US"/>
           </a:p>
         </p:txBody>
       </p:sp>
@@ -2729,7 +2523,7 @@
           <a:p>
             <a:pPr lvl="0"/>
             <a:r>
-              <a:rPr lang="en-US" smtClean="0"/>
+              <a:rPr lang="en-US"/>
               <a:t>Click to edit Master text styles</a:t>
             </a:r>
           </a:p>
@@ -2752,7 +2546,7 @@
           <a:p>
             <a:fld id="{5BCAD085-E8A6-8845-BD4E-CB4CCA059FC4}" type="datetimeFigureOut">
               <a:rPr lang="en-US" smtClean="0"/>
-              <a:t>1/27/13</a:t>
+              <a:t>5/25/2026</a:t>
             </a:fld>
             <a:endParaRPr lang="en-US"/>
           </a:p>
@@ -2846,10 +2640,9 @@
           <a:lstStyle/>
           <a:p>
             <a:r>
-              <a:rPr lang="en-US" smtClean="0"/>
+              <a:rPr lang="en-US"/>
               <a:t>Click to edit Master title style</a:t>
             </a:r>
-            <a:endParaRPr lang="en-US"/>
           </a:p>
         </p:txBody>
       </p:sp>
@@ -2903,38 +2696,37 @@
           <a:p>
             <a:pPr lvl="0"/>
             <a:r>
-              <a:rPr lang="en-US" smtClean="0"/>
+              <a:rPr lang="en-US"/>
               <a:t>Click to edit Master text styles</a:t>
             </a:r>
           </a:p>
           <a:p>
             <a:pPr lvl="1"/>
             <a:r>
-              <a:rPr lang="en-US" smtClean="0"/>
+              <a:rPr lang="en-US"/>
               <a:t>Second level</a:t>
             </a:r>
           </a:p>
           <a:p>
             <a:pPr lvl="2"/>
             <a:r>
-              <a:rPr lang="en-US" smtClean="0"/>
+              <a:rPr lang="en-US"/>
               <a:t>Third level</a:t>
             </a:r>
           </a:p>
           <a:p>
             <a:pPr lvl="3"/>
             <a:r>
-              <a:rPr lang="en-US" smtClean="0"/>
+              <a:rPr lang="en-US"/>
               <a:t>Fourth level</a:t>
             </a:r>
           </a:p>
           <a:p>
             <a:pPr lvl="4"/>
             <a:r>
-              <a:rPr lang="en-US" smtClean="0"/>
+              <a:rPr lang="en-US"/>
               <a:t>Fifth level</a:t>
             </a:r>
-            <a:endParaRPr lang="en-US"/>
           </a:p>
         </p:txBody>
       </p:sp>
@@ -2988,38 +2780,37 @@
           <a:p>
             <a:pPr lvl="0"/>
             <a:r>
-              <a:rPr lang="en-US" smtClean="0"/>
+              <a:rPr lang="en-US"/>
               <a:t>Click to edit Master text styles</a:t>
             </a:r>
           </a:p>
           <a:p>
             <a:pPr lvl="1"/>
             <a:r>
-              <a:rPr lang="en-US" smtClean="0"/>
+              <a:rPr lang="en-US"/>
               <a:t>Second level</a:t>
             </a:r>
           </a:p>
           <a:p>
             <a:pPr lvl="2"/>
             <a:r>
-              <a:rPr lang="en-US" smtClean="0"/>
+              <a:rPr lang="en-US"/>
               <a:t>Third level</a:t>
             </a:r>
           </a:p>
           <a:p>
             <a:pPr lvl="3"/>
             <a:r>
-              <a:rPr lang="en-US" smtClean="0"/>
+              <a:rPr lang="en-US"/>
               <a:t>Fourth level</a:t>
             </a:r>
           </a:p>
           <a:p>
             <a:pPr lvl="4"/>
             <a:r>
-              <a:rPr lang="en-US" smtClean="0"/>
+              <a:rPr lang="en-US"/>
               <a:t>Fifth level</a:t>
             </a:r>
-            <a:endParaRPr lang="en-US"/>
           </a:p>
         </p:txBody>
       </p:sp>
@@ -3040,7 +2831,7 @@
           <a:p>
             <a:fld id="{5BCAD085-E8A6-8845-BD4E-CB4CCA059FC4}" type="datetimeFigureOut">
               <a:rPr lang="en-US" smtClean="0"/>
-              <a:t>1/27/13</a:t>
+              <a:t>5/25/2026</a:t>
             </a:fld>
             <a:endParaRPr lang="en-US"/>
           </a:p>
@@ -3138,10 +2929,9 @@
           </a:lstStyle>
           <a:p>
             <a:r>
-              <a:rPr lang="en-US" smtClean="0"/>
+              <a:rPr lang="en-US"/>
               <a:t>Click to edit Master title style</a:t>
             </a:r>
-            <a:endParaRPr lang="en-US"/>
           </a:p>
         </p:txBody>
       </p:sp>
@@ -3204,7 +2994,7 @@
           <a:p>
             <a:pPr lvl="0"/>
             <a:r>
-              <a:rPr lang="en-US" smtClean="0"/>
+              <a:rPr lang="en-US"/>
               <a:t>Click to edit Master text styles</a:t>
             </a:r>
           </a:p>
@@ -3260,38 +3050,37 @@
           <a:p>
             <a:pPr lvl="0"/>
             <a:r>
-              <a:rPr lang="en-US" smtClean="0"/>
+              <a:rPr lang="en-US"/>
               <a:t>Click to edit Master text styles</a:t>
             </a:r>
           </a:p>
           <a:p>
             <a:pPr lvl="1"/>
             <a:r>
-              <a:rPr lang="en-US" smtClean="0"/>
+              <a:rPr lang="en-US"/>
               <a:t>Second level</a:t>
             </a:r>
           </a:p>
           <a:p>
             <a:pPr lvl="2"/>
             <a:r>
-              <a:rPr lang="en-US" smtClean="0"/>
+              <a:rPr lang="en-US"/>
               <a:t>Third level</a:t>
             </a:r>
           </a:p>
           <a:p>
             <a:pPr lvl="3"/>
             <a:r>
-              <a:rPr lang="en-US" smtClean="0"/>
+              <a:rPr lang="en-US"/>
               <a:t>Fourth level</a:t>
             </a:r>
           </a:p>
           <a:p>
             <a:pPr lvl="4"/>
             <a:r>
-              <a:rPr lang="en-US" smtClean="0"/>
+              <a:rPr lang="en-US"/>
               <a:t>Fifth level</a:t>
             </a:r>
-            <a:endParaRPr lang="en-US"/>
           </a:p>
         </p:txBody>
       </p:sp>
@@ -3354,7 +3143,7 @@
           <a:p>
             <a:pPr lvl="0"/>
             <a:r>
-              <a:rPr lang="en-US" smtClean="0"/>
+              <a:rPr lang="en-US"/>
               <a:t>Click to edit Master text styles</a:t>
             </a:r>
           </a:p>
@@ -3410,38 +3199,37 @@
           <a:p>
             <a:pPr lvl="0"/>
             <a:r>
-              <a:rPr lang="en-US" smtClean="0"/>
+              <a:rPr lang="en-US"/>
               <a:t>Click to edit Master text styles</a:t>
             </a:r>
           </a:p>
           <a:p>
             <a:pPr lvl="1"/>
             <a:r>
-              <a:rPr lang="en-US" smtClean="0"/>
+              <a:rPr lang="en-US"/>
               <a:t>Second level</a:t>
             </a:r>
           </a:p>
           <a:p>
             <a:pPr lvl="2"/>
             <a:r>
-              <a:rPr lang="en-US" smtClean="0"/>
+              <a:rPr lang="en-US"/>
               <a:t>Third level</a:t>
             </a:r>
           </a:p>
           <a:p>
             <a:pPr lvl="3"/>
             <a:r>
-              <a:rPr lang="en-US" smtClean="0"/>
+              <a:rPr lang="en-US"/>
               <a:t>Fourth level</a:t>
             </a:r>
           </a:p>
           <a:p>
             <a:pPr lvl="4"/>
             <a:r>
-              <a:rPr lang="en-US" smtClean="0"/>
+              <a:rPr lang="en-US"/>
               <a:t>Fifth level</a:t>
             </a:r>
-            <a:endParaRPr lang="en-US"/>
           </a:p>
         </p:txBody>
       </p:sp>
@@ -3462,7 +3250,7 @@
           <a:p>
             <a:fld id="{5BCAD085-E8A6-8845-BD4E-CB4CCA059FC4}" type="datetimeFigureOut">
               <a:rPr lang="en-US" smtClean="0"/>
-              <a:t>1/27/13</a:t>
+              <a:t>5/25/2026</a:t>
             </a:fld>
             <a:endParaRPr lang="en-US"/>
           </a:p>
@@ -3556,10 +3344,9 @@
           <a:lstStyle/>
           <a:p>
             <a:r>
-              <a:rPr lang="en-US" smtClean="0"/>
+              <a:rPr lang="en-US"/>
               <a:t>Click to edit Master title style</a:t>
             </a:r>
-            <a:endParaRPr lang="en-US"/>
           </a:p>
         </p:txBody>
       </p:sp>
@@ -3580,7 +3367,7 @@
           <a:p>
             <a:fld id="{5BCAD085-E8A6-8845-BD4E-CB4CCA059FC4}" type="datetimeFigureOut">
               <a:rPr lang="en-US" smtClean="0"/>
-              <a:t>1/27/13</a:t>
+              <a:t>5/25/2026</a:t>
             </a:fld>
             <a:endParaRPr lang="en-US"/>
           </a:p>
@@ -3675,7 +3462,7 @@
           <a:p>
             <a:fld id="{5BCAD085-E8A6-8845-BD4E-CB4CCA059FC4}" type="datetimeFigureOut">
               <a:rPr lang="en-US" smtClean="0"/>
-              <a:t>1/27/13</a:t>
+              <a:t>5/25/2026</a:t>
             </a:fld>
             <a:endParaRPr lang="en-US"/>
           </a:p>
@@ -3778,10 +3565,9 @@
           </a:lstStyle>
           <a:p>
             <a:r>
-              <a:rPr lang="en-US" smtClean="0"/>
+              <a:rPr lang="en-US"/>
               <a:t>Click to edit Master title style</a:t>
             </a:r>
-            <a:endParaRPr lang="en-US"/>
           </a:p>
         </p:txBody>
       </p:sp>
@@ -3835,38 +3621,37 @@
           <a:p>
             <a:pPr lvl="0"/>
             <a:r>
-              <a:rPr lang="en-US" smtClean="0"/>
+              <a:rPr lang="en-US"/>
               <a:t>Click to edit Master text styles</a:t>
             </a:r>
           </a:p>
           <a:p>
             <a:pPr lvl="1"/>
             <a:r>
-              <a:rPr lang="en-US" smtClean="0"/>
+              <a:rPr lang="en-US"/>
               <a:t>Second level</a:t>
             </a:r>
           </a:p>
           <a:p>
             <a:pPr lvl="2"/>
             <a:r>
-              <a:rPr lang="en-US" smtClean="0"/>
+              <a:rPr lang="en-US"/>
               <a:t>Third level</a:t>
             </a:r>
           </a:p>
           <a:p>
             <a:pPr lvl="3"/>
             <a:r>
-              <a:rPr lang="en-US" smtClean="0"/>
+              <a:rPr lang="en-US"/>
               <a:t>Fourth level</a:t>
             </a:r>
           </a:p>
           <a:p>
             <a:pPr lvl="4"/>
             <a:r>
-              <a:rPr lang="en-US" smtClean="0"/>
+              <a:rPr lang="en-US"/>
               <a:t>Fifth level</a:t>
             </a:r>
-            <a:endParaRPr lang="en-US"/>
           </a:p>
         </p:txBody>
       </p:sp>
@@ -3929,7 +3714,7 @@
           <a:p>
             <a:pPr lvl="0"/>
             <a:r>
-              <a:rPr lang="en-US" smtClean="0"/>
+              <a:rPr lang="en-US"/>
               <a:t>Click to edit Master text styles</a:t>
             </a:r>
           </a:p>
@@ -3952,7 +3737,7 @@
           <a:p>
             <a:fld id="{5BCAD085-E8A6-8845-BD4E-CB4CCA059FC4}" type="datetimeFigureOut">
               <a:rPr lang="en-US" smtClean="0"/>
-              <a:t>1/27/13</a:t>
+              <a:t>5/25/2026</a:t>
             </a:fld>
             <a:endParaRPr lang="en-US"/>
           </a:p>
@@ -4055,10 +3840,9 @@
           </a:lstStyle>
           <a:p>
             <a:r>
-              <a:rPr lang="en-US" smtClean="0"/>
+              <a:rPr lang="en-US"/>
               <a:t>Click to edit Master title style</a:t>
             </a:r>
-            <a:endParaRPr lang="en-US"/>
           </a:p>
         </p:txBody>
       </p:sp>
@@ -4182,7 +3966,7 @@
           <a:p>
             <a:pPr lvl="0"/>
             <a:r>
-              <a:rPr lang="en-US" smtClean="0"/>
+              <a:rPr lang="en-US"/>
               <a:t>Click to edit Master text styles</a:t>
             </a:r>
           </a:p>
@@ -4205,7 +3989,7 @@
           <a:p>
             <a:fld id="{5BCAD085-E8A6-8845-BD4E-CB4CCA059FC4}" type="datetimeFigureOut">
               <a:rPr lang="en-US" smtClean="0"/>
-              <a:t>1/27/13</a:t>
+              <a:t>5/25/2026</a:t>
             </a:fld>
             <a:endParaRPr lang="en-US"/>
           </a:p>
@@ -4314,10 +4098,9 @@
           <a:lstStyle/>
           <a:p>
             <a:r>
-              <a:rPr lang="en-US" smtClean="0"/>
+              <a:rPr lang="en-US"/>
               <a:t>Click to edit Master title style</a:t>
             </a:r>
-            <a:endParaRPr lang="en-US"/>
           </a:p>
         </p:txBody>
       </p:sp>
@@ -4348,38 +4131,37 @@
           <a:p>
             <a:pPr lvl="0"/>
             <a:r>
-              <a:rPr lang="en-US" smtClean="0"/>
+              <a:rPr lang="en-US"/>
               <a:t>Click to edit Master text styles</a:t>
             </a:r>
           </a:p>
           <a:p>
             <a:pPr lvl="1"/>
             <a:r>
-              <a:rPr lang="en-US" smtClean="0"/>
+              <a:rPr lang="en-US"/>
               <a:t>Second level</a:t>
             </a:r>
           </a:p>
           <a:p>
             <a:pPr lvl="2"/>
             <a:r>
-              <a:rPr lang="en-US" smtClean="0"/>
+              <a:rPr lang="en-US"/>
               <a:t>Third level</a:t>
             </a:r>
           </a:p>
           <a:p>
             <a:pPr lvl="3"/>
             <a:r>
-              <a:rPr lang="en-US" smtClean="0"/>
+              <a:rPr lang="en-US"/>
               <a:t>Fourth level</a:t>
             </a:r>
           </a:p>
           <a:p>
             <a:pPr lvl="4"/>
             <a:r>
-              <a:rPr lang="en-US" smtClean="0"/>
+              <a:rPr lang="en-US"/>
               <a:t>Fifth level</a:t>
             </a:r>
-            <a:endParaRPr lang="en-US"/>
           </a:p>
         </p:txBody>
       </p:sp>
@@ -4418,7 +4200,7 @@
           <a:p>
             <a:fld id="{5BCAD085-E8A6-8845-BD4E-CB4CCA059FC4}" type="datetimeFigureOut">
               <a:rPr lang="en-US" smtClean="0"/>
-              <a:t>1/27/13</a:t>
+              <a:t>5/25/2026</a:t>
             </a:fld>
             <a:endParaRPr lang="en-US"/>
           </a:p>
@@ -4777,7 +4559,7 @@
 </file>
 
 <file path=ppt/slides/slide1.xml><?xml version="1.0" encoding="utf-8"?>
-<p:sld xmlns:a="http://schemas.openxmlformats.org/drawingml/2006/main" xmlns:p="http://schemas.openxmlformats.org/presentationml/2006/main" xmlns:r="http://schemas.openxmlformats.org/officeDocument/2006/relationships">
+<p:sld xmlns:a="http://schemas.openxmlformats.org/drawingml/2006/main" xmlns:r="http://schemas.openxmlformats.org/officeDocument/2006/relationships" xmlns:p="http://schemas.openxmlformats.org/presentationml/2006/main">
   <p:cSld>
     <p:bg>
       <p:bgPr>
@@ -4793,7 +4575,14 @@
         <p:cNvGrpSpPr/>
         <p:nvPr/>
       </p:nvGrpSpPr>
-      <p:grpSpPr/>
+      <p:grpSpPr>
+        <a:xfrm>
+          <a:off x="0" y="0"/>
+          <a:ext cx="0" cy="0"/>
+          <a:chOff x="0" y="0"/>
+          <a:chExt cx="0" cy="0"/>
+        </a:xfrm>
+      </p:grpSpPr>
       <p:sp>
         <p:nvSpPr>
           <p:cNvPr id="2" name="TextBox 1"/>
@@ -4979,7 +4768,7 @@
 </file>
 
 <file path=ppt/slides/slide10.xml><?xml version="1.0" encoding="utf-8"?>
-<p:sld xmlns:a="http://schemas.openxmlformats.org/drawingml/2006/main" xmlns:p="http://schemas.openxmlformats.org/presentationml/2006/main" xmlns:r="http://schemas.openxmlformats.org/officeDocument/2006/relationships">
+<p:sld xmlns:a="http://schemas.openxmlformats.org/drawingml/2006/main" xmlns:r="http://schemas.openxmlformats.org/officeDocument/2006/relationships" xmlns:p="http://schemas.openxmlformats.org/presentationml/2006/main">
   <p:cSld>
     <p:bg>
       <p:bgPr>
@@ -4995,7 +4784,14 @@
         <p:cNvGrpSpPr/>
         <p:nvPr/>
       </p:nvGrpSpPr>
-      <p:grpSpPr/>
+      <p:grpSpPr>
+        <a:xfrm>
+          <a:off x="0" y="0"/>
+          <a:ext cx="0" cy="0"/>
+          <a:chOff x="0" y="0"/>
+          <a:chExt cx="0" cy="0"/>
+        </a:xfrm>
+      </p:grpSpPr>
       <p:sp>
         <p:nvSpPr>
           <p:cNvPr id="2" name="TextBox 1"/>
@@ -5152,20 +4948,8 @@
           </a:fontRef>
         </p:style>
         <p:txBody>
-          <a:bodyPr rtlCol="0" anchor="ctr" wrap="square" lIns="101600" rIns="101600" tIns="76200" bIns="76200"/>
-          <a:lstStyle/>
-          <a:p>
-            <a:pPr algn="ctr">
-              <a:defRPr sz="1100" b="1">
-                <a:solidFill>
-                  <a:srgbClr val="0071BC"/>
-                </a:solidFill>
-              </a:defRPr>
-            </a:pPr>
-            <a:r>
-              <a:t>Takeaway</a:t>
-            </a:r>
-          </a:p>
+          <a:bodyPr wrap="square" lIns="101600" tIns="76200" rIns="101600" bIns="76200" rtlCol="0" anchor="ctr"/>
+          <a:lstStyle/>
           <a:p>
             <a:pPr>
               <a:spcBef>
@@ -5178,6 +4962,7 @@
               </a:defRPr>
             </a:pPr>
             <a:r>
+              <a:rPr dirty="0"/>
               <a:t>Edge chipping is not random — it clusters in high tool-life and unstable coolant windows.</a:t>
             </a:r>
           </a:p>
@@ -5223,6 +5008,7 @@
           <a:lstStyle/>
           <a:p>
             <a:pPr algn="ctr"/>
+            <a:endParaRPr/>
           </a:p>
         </p:txBody>
       </p:sp>
@@ -5235,7 +5021,7 @@
           <p:nvPr/>
         </p:nvPicPr>
         <p:blipFill>
-          <a:blip r:embed="rId2"/>
+          <a:blip r:embed="rId3"/>
           <a:stretch>
             <a:fillRect/>
           </a:stretch>
@@ -5329,7 +5115,7 @@
 </file>
 
 <file path=ppt/slides/slide11.xml><?xml version="1.0" encoding="utf-8"?>
-<p:sld xmlns:a="http://schemas.openxmlformats.org/drawingml/2006/main" xmlns:p="http://schemas.openxmlformats.org/presentationml/2006/main" xmlns:r="http://schemas.openxmlformats.org/officeDocument/2006/relationships">
+<p:sld xmlns:a="http://schemas.openxmlformats.org/drawingml/2006/main" xmlns:r="http://schemas.openxmlformats.org/officeDocument/2006/relationships" xmlns:p="http://schemas.openxmlformats.org/presentationml/2006/main">
   <p:cSld>
     <p:bg>
       <p:bgPr>
@@ -5345,7 +5131,14 @@
         <p:cNvGrpSpPr/>
         <p:nvPr/>
       </p:nvGrpSpPr>
-      <p:grpSpPr/>
+      <p:grpSpPr>
+        <a:xfrm>
+          <a:off x="0" y="0"/>
+          <a:ext cx="0" cy="0"/>
+          <a:chOff x="0" y="0"/>
+          <a:chExt cx="0" cy="0"/>
+        </a:xfrm>
+      </p:grpSpPr>
       <p:sp>
         <p:nvSpPr>
           <p:cNvPr id="2" name="TextBox 1"/>
@@ -5502,20 +5295,8 @@
           </a:fontRef>
         </p:style>
         <p:txBody>
-          <a:bodyPr rtlCol="0" anchor="ctr" wrap="square" lIns="101600" rIns="101600" tIns="76200" bIns="76200"/>
-          <a:lstStyle/>
-          <a:p>
-            <a:pPr algn="ctr">
-              <a:defRPr sz="1100" b="1">
-                <a:solidFill>
-                  <a:srgbClr val="0071BC"/>
-                </a:solidFill>
-              </a:defRPr>
-            </a:pPr>
-            <a:r>
-              <a:t>Takeaway</a:t>
-            </a:r>
-          </a:p>
+          <a:bodyPr wrap="square" lIns="101600" tIns="76200" rIns="101600" bIns="76200" rtlCol="0" anchor="ctr"/>
+          <a:lstStyle/>
           <a:p>
             <a:pPr>
               <a:spcBef>
@@ -5528,6 +5309,7 @@
               </a:defRPr>
             </a:pPr>
             <a:r>
+              <a:rPr dirty="0"/>
               <a:t>Use p-chart for chipping rate; control limits are process-derived, not spec limits.</a:t>
             </a:r>
           </a:p>
@@ -5573,6 +5355,7 @@
           <a:lstStyle/>
           <a:p>
             <a:pPr algn="ctr"/>
+            <a:endParaRPr/>
           </a:p>
         </p:txBody>
       </p:sp>
@@ -5585,7 +5368,7 @@
           <p:nvPr/>
         </p:nvPicPr>
         <p:blipFill>
-          <a:blip r:embed="rId2"/>
+          <a:blip r:embed="rId3"/>
           <a:stretch>
             <a:fillRect/>
           </a:stretch>
@@ -5679,7 +5462,7 @@
 </file>
 
 <file path=ppt/slides/slide12.xml><?xml version="1.0" encoding="utf-8"?>
-<p:sld xmlns:a="http://schemas.openxmlformats.org/drawingml/2006/main" xmlns:p="http://schemas.openxmlformats.org/presentationml/2006/main" xmlns:r="http://schemas.openxmlformats.org/officeDocument/2006/relationships">
+<p:sld xmlns:a="http://schemas.openxmlformats.org/drawingml/2006/main" xmlns:r="http://schemas.openxmlformats.org/officeDocument/2006/relationships" xmlns:p="http://schemas.openxmlformats.org/presentationml/2006/main">
   <p:cSld>
     <p:bg>
       <p:bgPr>
@@ -5695,7 +5478,14 @@
         <p:cNvGrpSpPr/>
         <p:nvPr/>
       </p:nvGrpSpPr>
-      <p:grpSpPr/>
+      <p:grpSpPr>
+        <a:xfrm>
+          <a:off x="0" y="0"/>
+          <a:ext cx="0" cy="0"/>
+          <a:chOff x="0" y="0"/>
+          <a:chExt cx="0" cy="0"/>
+        </a:xfrm>
+      </p:grpSpPr>
       <p:sp>
         <p:nvSpPr>
           <p:cNvPr id="2" name="TextBox 1"/>
@@ -5852,7 +5642,7 @@
           </a:fontRef>
         </p:style>
         <p:txBody>
-          <a:bodyPr rtlCol="0" anchor="ctr" wrap="square" lIns="101600" rIns="101600" tIns="76200" bIns="76200"/>
+          <a:bodyPr wrap="square" lIns="101600" tIns="76200" rIns="101600" bIns="76200" rtlCol="0" anchor="ctr"/>
           <a:lstStyle/>
           <a:p>
             <a:pPr algn="ctr">
@@ -5862,9 +5652,7 @@
                 </a:solidFill>
               </a:defRPr>
             </a:pPr>
-            <a:r>
-              <a:t>Takeaway</a:t>
-            </a:r>
+            <a:endParaRPr dirty="0"/>
           </a:p>
           <a:p>
             <a:pPr>
@@ -5878,6 +5666,7 @@
               </a:defRPr>
             </a:pPr>
             <a:r>
+              <a:rPr dirty="0"/>
               <a:t>High-risk window shifts mean toward USL — capability drops even if spread looks OK.</a:t>
             </a:r>
           </a:p>
@@ -5923,6 +5712,7 @@
           <a:lstStyle/>
           <a:p>
             <a:pPr algn="ctr"/>
+            <a:endParaRPr/>
           </a:p>
         </p:txBody>
       </p:sp>
@@ -5935,7 +5725,7 @@
           <p:nvPr/>
         </p:nvPicPr>
         <p:blipFill>
-          <a:blip r:embed="rId2"/>
+          <a:blip r:embed="rId3"/>
           <a:stretch>
             <a:fillRect/>
           </a:stretch>
@@ -6029,7 +5819,7 @@
 </file>
 
 <file path=ppt/slides/slide13.xml><?xml version="1.0" encoding="utf-8"?>
-<p:sld xmlns:a="http://schemas.openxmlformats.org/drawingml/2006/main" xmlns:p="http://schemas.openxmlformats.org/presentationml/2006/main" xmlns:r="http://schemas.openxmlformats.org/officeDocument/2006/relationships">
+<p:sld xmlns:a="http://schemas.openxmlformats.org/drawingml/2006/main" xmlns:r="http://schemas.openxmlformats.org/officeDocument/2006/relationships" xmlns:p="http://schemas.openxmlformats.org/presentationml/2006/main">
   <p:cSld>
     <p:bg>
       <p:bgPr>
@@ -6045,7 +5835,14 @@
         <p:cNvGrpSpPr/>
         <p:nvPr/>
       </p:nvGrpSpPr>
-      <p:grpSpPr/>
+      <p:grpSpPr>
+        <a:xfrm>
+          <a:off x="0" y="0"/>
+          <a:ext cx="0" cy="0"/>
+          <a:chOff x="0" y="0"/>
+          <a:chExt cx="0" cy="0"/>
+        </a:xfrm>
+      </p:grpSpPr>
       <p:sp>
         <p:nvSpPr>
           <p:cNvPr id="2" name="TextBox 1"/>
@@ -6202,7 +5999,7 @@
           </a:fontRef>
         </p:style>
         <p:txBody>
-          <a:bodyPr rtlCol="0" anchor="ctr" wrap="square" lIns="101600" rIns="101600" tIns="76200" bIns="76200"/>
+          <a:bodyPr wrap="square" lIns="101600" tIns="76200" rIns="101600" bIns="76200" rtlCol="0" anchor="ctr"/>
           <a:lstStyle/>
           <a:p>
             <a:pPr algn="ctr">
@@ -6212,9 +6009,7 @@
                 </a:solidFill>
               </a:defRPr>
             </a:pPr>
-            <a:r>
-              <a:t>Takeaway</a:t>
-            </a:r>
+            <a:endParaRPr dirty="0"/>
           </a:p>
           <a:p>
             <a:pPr>
@@ -6228,6 +6023,7 @@
               </a:defRPr>
             </a:pPr>
             <a:r>
+              <a:rPr dirty="0"/>
               <a:t>Defects cluster on edges and corners — consistent with CNC contouring, not random handling.</a:t>
             </a:r>
           </a:p>
@@ -6273,6 +6069,7 @@
           <a:lstStyle/>
           <a:p>
             <a:pPr algn="ctr"/>
+            <a:endParaRPr/>
           </a:p>
         </p:txBody>
       </p:sp>
@@ -6285,7 +6082,7 @@
           <p:nvPr/>
         </p:nvPicPr>
         <p:blipFill>
-          <a:blip r:embed="rId2"/>
+          <a:blip r:embed="rId3"/>
           <a:stretch>
             <a:fillRect/>
           </a:stretch>
@@ -6379,7 +6176,7 @@
 </file>
 
 <file path=ppt/slides/slide14.xml><?xml version="1.0" encoding="utf-8"?>
-<p:sld xmlns:a="http://schemas.openxmlformats.org/drawingml/2006/main" xmlns:p="http://schemas.openxmlformats.org/presentationml/2006/main" xmlns:r="http://schemas.openxmlformats.org/officeDocument/2006/relationships">
+<p:sld xmlns:a="http://schemas.openxmlformats.org/drawingml/2006/main" xmlns:r="http://schemas.openxmlformats.org/officeDocument/2006/relationships" xmlns:p="http://schemas.openxmlformats.org/presentationml/2006/main">
   <p:cSld>
     <p:bg>
       <p:bgPr>
@@ -6395,7 +6192,14 @@
         <p:cNvGrpSpPr/>
         <p:nvPr/>
       </p:nvGrpSpPr>
-      <p:grpSpPr/>
+      <p:grpSpPr>
+        <a:xfrm>
+          <a:off x="0" y="0"/>
+          <a:ext cx="0" cy="0"/>
+          <a:chOff x="0" y="0"/>
+          <a:chExt cx="0" cy="0"/>
+        </a:xfrm>
+      </p:grpSpPr>
       <p:sp>
         <p:nvSpPr>
           <p:cNvPr id="2" name="TextBox 1"/>
@@ -6552,7 +6356,7 @@
           </a:fontRef>
         </p:style>
         <p:txBody>
-          <a:bodyPr rtlCol="0" anchor="ctr" wrap="square" lIns="101600" rIns="101600" tIns="76200" bIns="76200"/>
+          <a:bodyPr wrap="square" lIns="101600" tIns="76200" rIns="101600" bIns="76200" rtlCol="0" anchor="ctr"/>
           <a:lstStyle/>
           <a:p>
             <a:pPr algn="ctr">
@@ -6562,9 +6366,7 @@
                 </a:solidFill>
               </a:defRPr>
             </a:pPr>
-            <a:r>
-              <a:t>Takeaway</a:t>
-            </a:r>
+            <a:endParaRPr dirty="0"/>
           </a:p>
           <a:p>
             <a:pPr>
@@ -6578,6 +6380,7 @@
               </a:defRPr>
             </a:pPr>
             <a:r>
+              <a:rPr dirty="0"/>
               <a:t>ML is a screening aid — rank high-risk windows, not automatic process control.</a:t>
             </a:r>
           </a:p>
@@ -6623,6 +6426,7 @@
           <a:lstStyle/>
           <a:p>
             <a:pPr algn="ctr"/>
+            <a:endParaRPr/>
           </a:p>
         </p:txBody>
       </p:sp>
@@ -6635,7 +6439,7 @@
           <p:nvPr/>
         </p:nvPicPr>
         <p:blipFill>
-          <a:blip r:embed="rId2"/>
+          <a:blip r:embed="rId3"/>
           <a:stretch>
             <a:fillRect/>
           </a:stretch>
@@ -6729,7 +6533,7 @@
 </file>
 
 <file path=ppt/slides/slide15.xml><?xml version="1.0" encoding="utf-8"?>
-<p:sld xmlns:a="http://schemas.openxmlformats.org/drawingml/2006/main" xmlns:p="http://schemas.openxmlformats.org/presentationml/2006/main" xmlns:r="http://schemas.openxmlformats.org/officeDocument/2006/relationships">
+<p:sld xmlns:a="http://schemas.openxmlformats.org/drawingml/2006/main" xmlns:r="http://schemas.openxmlformats.org/officeDocument/2006/relationships" xmlns:p="http://schemas.openxmlformats.org/presentationml/2006/main">
   <p:cSld>
     <p:bg>
       <p:bgPr>
@@ -6745,7 +6549,14 @@
         <p:cNvGrpSpPr/>
         <p:nvPr/>
       </p:nvGrpSpPr>
-      <p:grpSpPr/>
+      <p:grpSpPr>
+        <a:xfrm>
+          <a:off x="0" y="0"/>
+          <a:ext cx="0" cy="0"/>
+          <a:chOff x="0" y="0"/>
+          <a:chExt cx="0" cy="0"/>
+        </a:xfrm>
+      </p:grpSpPr>
       <p:sp>
         <p:nvSpPr>
           <p:cNvPr id="2" name="TextBox 1"/>
@@ -6887,7 +6698,7 @@
           </a:fontRef>
         </p:style>
         <p:txBody>
-          <a:bodyPr rtlCol="0" anchor="ctr" wrap="square" lIns="101600" rIns="101600" tIns="76200" bIns="76200"/>
+          <a:bodyPr wrap="square" lIns="101600" tIns="76200" rIns="101600" bIns="76200" rtlCol="0" anchor="ctr"/>
           <a:lstStyle/>
           <a:p>
             <a:pPr algn="ctr">
@@ -6897,9 +6708,7 @@
                 </a:solidFill>
               </a:defRPr>
             </a:pPr>
-            <a:r>
-              <a:t>Takeaway</a:t>
-            </a:r>
+            <a:endParaRPr dirty="0"/>
           </a:p>
           <a:p>
             <a:pPr>
@@ -6913,6 +6722,7 @@
               </a:defRPr>
             </a:pPr>
             <a:r>
+              <a:rPr dirty="0"/>
               <a:t>JMP supports live engineering review — Python stays the source of truth for calculations.</a:t>
             </a:r>
           </a:p>
@@ -6958,6 +6768,7 @@
           <a:lstStyle/>
           <a:p>
             <a:pPr algn="ctr"/>
+            <a:endParaRPr/>
           </a:p>
         </p:txBody>
       </p:sp>
@@ -6970,7 +6781,7 @@
           <p:nvPr/>
         </p:nvPicPr>
         <p:blipFill>
-          <a:blip r:embed="rId2"/>
+          <a:blip r:embed="rId3"/>
           <a:stretch>
             <a:fillRect/>
           </a:stretch>
@@ -7060,6 +6871,7 @@
           <a:lstStyle/>
           <a:p>
             <a:pPr algn="ctr"/>
+            <a:endParaRPr/>
           </a:p>
         </p:txBody>
       </p:sp>
@@ -7072,7 +6884,7 @@
           <p:nvPr/>
         </p:nvPicPr>
         <p:blipFill>
-          <a:blip r:embed="rId3"/>
+          <a:blip r:embed="rId4"/>
           <a:stretch>
             <a:fillRect/>
           </a:stretch>
@@ -7166,7 +6978,7 @@
 </file>
 
 <file path=ppt/slides/slide16.xml><?xml version="1.0" encoding="utf-8"?>
-<p:sld xmlns:a="http://schemas.openxmlformats.org/drawingml/2006/main" xmlns:p="http://schemas.openxmlformats.org/presentationml/2006/main" xmlns:r="http://schemas.openxmlformats.org/officeDocument/2006/relationships">
+<p:sld xmlns:a="http://schemas.openxmlformats.org/drawingml/2006/main" xmlns:r="http://schemas.openxmlformats.org/officeDocument/2006/relationships" xmlns:p="http://schemas.openxmlformats.org/presentationml/2006/main">
   <p:cSld>
     <p:bg>
       <p:bgPr>
@@ -7182,7 +6994,14 @@
         <p:cNvGrpSpPr/>
         <p:nvPr/>
       </p:nvGrpSpPr>
-      <p:grpSpPr/>
+      <p:grpSpPr>
+        <a:xfrm>
+          <a:off x="0" y="0"/>
+          <a:ext cx="0" cy="0"/>
+          <a:chOff x="0" y="0"/>
+          <a:chExt cx="0" cy="0"/>
+        </a:xfrm>
+      </p:grpSpPr>
       <p:sp>
         <p:nvSpPr>
           <p:cNvPr id="2" name="TextBox 1"/>
@@ -7324,7 +7143,7 @@
           </a:fontRef>
         </p:style>
         <p:txBody>
-          <a:bodyPr rtlCol="0" anchor="ctr" wrap="square" lIns="101600" rIns="101600" tIns="76200" bIns="76200"/>
+          <a:bodyPr wrap="square" lIns="101600" tIns="76200" rIns="101600" bIns="76200" rtlCol="0" anchor="ctr"/>
           <a:lstStyle/>
           <a:p>
             <a:pPr algn="ctr">
@@ -7334,9 +7153,7 @@
                 </a:solidFill>
               </a:defRPr>
             </a:pPr>
-            <a:r>
-              <a:t>Takeaway</a:t>
-            </a:r>
+            <a:endParaRPr dirty="0"/>
           </a:p>
           <a:p>
             <a:pPr>
@@ -7350,6 +7167,7 @@
               </a:defRPr>
             </a:pPr>
             <a:r>
+              <a:rPr dirty="0"/>
               <a:t>MQE action: contain now, fix tooling/coolant/fixtures, then lock in preventive controls.</a:t>
             </a:r>
           </a:p>
@@ -7399,7 +7217,7 @@
 </file>
 
 <file path=ppt/slides/slide17.xml><?xml version="1.0" encoding="utf-8"?>
-<p:sld xmlns:a="http://schemas.openxmlformats.org/drawingml/2006/main" xmlns:p="http://schemas.openxmlformats.org/presentationml/2006/main" xmlns:r="http://schemas.openxmlformats.org/officeDocument/2006/relationships">
+<p:sld xmlns:a="http://schemas.openxmlformats.org/drawingml/2006/main" xmlns:r="http://schemas.openxmlformats.org/officeDocument/2006/relationships" xmlns:p="http://schemas.openxmlformats.org/presentationml/2006/main">
   <p:cSld>
     <p:bg>
       <p:bgPr>
@@ -7415,7 +7233,14 @@
         <p:cNvGrpSpPr/>
         <p:nvPr/>
       </p:nvGrpSpPr>
-      <p:grpSpPr/>
+      <p:grpSpPr>
+        <a:xfrm>
+          <a:off x="0" y="0"/>
+          <a:ext cx="0" cy="0"/>
+          <a:chOff x="0" y="0"/>
+          <a:chExt cx="0" cy="0"/>
+        </a:xfrm>
+      </p:grpSpPr>
       <p:sp>
         <p:nvSpPr>
           <p:cNvPr id="2" name="TextBox 1"/>
@@ -7563,7 +7388,7 @@
 </file>
 
 <file path=ppt/slides/slide18.xml><?xml version="1.0" encoding="utf-8"?>
-<p:sld xmlns:a="http://schemas.openxmlformats.org/drawingml/2006/main" xmlns:p="http://schemas.openxmlformats.org/presentationml/2006/main" xmlns:r="http://schemas.openxmlformats.org/officeDocument/2006/relationships">
+<p:sld xmlns:a="http://schemas.openxmlformats.org/drawingml/2006/main" xmlns:r="http://schemas.openxmlformats.org/officeDocument/2006/relationships" xmlns:p="http://schemas.openxmlformats.org/presentationml/2006/main">
   <p:cSld>
     <p:bg>
       <p:bgPr>
@@ -7579,7 +7404,14 @@
         <p:cNvGrpSpPr/>
         <p:nvPr/>
       </p:nvGrpSpPr>
-      <p:grpSpPr/>
+      <p:grpSpPr>
+        <a:xfrm>
+          <a:off x="0" y="0"/>
+          <a:ext cx="0" cy="0"/>
+          <a:chOff x="0" y="0"/>
+          <a:chExt cx="0" cy="0"/>
+        </a:xfrm>
+      </p:grpSpPr>
       <p:sp>
         <p:nvSpPr>
           <p:cNvPr id="2" name="TextBox 1"/>
@@ -7742,7 +7574,7 @@
 </file>
 
 <file path=ppt/slides/slide19.xml><?xml version="1.0" encoding="utf-8"?>
-<p:sld xmlns:a="http://schemas.openxmlformats.org/drawingml/2006/main" xmlns:p="http://schemas.openxmlformats.org/presentationml/2006/main" xmlns:r="http://schemas.openxmlformats.org/officeDocument/2006/relationships">
+<p:sld xmlns:a="http://schemas.openxmlformats.org/drawingml/2006/main" xmlns:r="http://schemas.openxmlformats.org/officeDocument/2006/relationships" xmlns:p="http://schemas.openxmlformats.org/presentationml/2006/main">
   <p:cSld>
     <p:bg>
       <p:bgPr>
@@ -7758,7 +7590,14 @@
         <p:cNvGrpSpPr/>
         <p:nvPr/>
       </p:nvGrpSpPr>
-      <p:grpSpPr/>
+      <p:grpSpPr>
+        <a:xfrm>
+          <a:off x="0" y="0"/>
+          <a:ext cx="0" cy="0"/>
+          <a:chOff x="0" y="0"/>
+          <a:chExt cx="0" cy="0"/>
+        </a:xfrm>
+      </p:grpSpPr>
       <p:sp>
         <p:nvSpPr>
           <p:cNvPr id="2" name="TextBox 1"/>
@@ -7908,7 +7747,7 @@
 </file>
 
 <file path=ppt/slides/slide2.xml><?xml version="1.0" encoding="utf-8"?>
-<p:sld xmlns:a="http://schemas.openxmlformats.org/drawingml/2006/main" xmlns:p="http://schemas.openxmlformats.org/presentationml/2006/main" xmlns:r="http://schemas.openxmlformats.org/officeDocument/2006/relationships">
+<p:sld xmlns:a="http://schemas.openxmlformats.org/drawingml/2006/main" xmlns:r="http://schemas.openxmlformats.org/officeDocument/2006/relationships" xmlns:p="http://schemas.openxmlformats.org/presentationml/2006/main">
   <p:cSld>
     <p:bg>
       <p:bgPr>
@@ -7924,7 +7763,14 @@
         <p:cNvGrpSpPr/>
         <p:nvPr/>
       </p:nvGrpSpPr>
-      <p:grpSpPr/>
+      <p:grpSpPr>
+        <a:xfrm>
+          <a:off x="0" y="0"/>
+          <a:ext cx="0" cy="0"/>
+          <a:chOff x="0" y="0"/>
+          <a:chExt cx="0" cy="0"/>
+        </a:xfrm>
+      </p:grpSpPr>
       <p:sp>
         <p:nvSpPr>
           <p:cNvPr id="2" name="TextBox 1"/>
@@ -8072,7 +7918,7 @@
 </file>
 
 <file path=ppt/slides/slide3.xml><?xml version="1.0" encoding="utf-8"?>
-<p:sld xmlns:a="http://schemas.openxmlformats.org/drawingml/2006/main" xmlns:p="http://schemas.openxmlformats.org/presentationml/2006/main" xmlns:r="http://schemas.openxmlformats.org/officeDocument/2006/relationships">
+<p:sld xmlns:a="http://schemas.openxmlformats.org/drawingml/2006/main" xmlns:r="http://schemas.openxmlformats.org/officeDocument/2006/relationships" xmlns:p="http://schemas.openxmlformats.org/presentationml/2006/main">
   <p:cSld>
     <p:bg>
       <p:bgPr>
@@ -8088,7 +7934,14 @@
         <p:cNvGrpSpPr/>
         <p:nvPr/>
       </p:nvGrpSpPr>
-      <p:grpSpPr/>
+      <p:grpSpPr>
+        <a:xfrm>
+          <a:off x="0" y="0"/>
+          <a:ext cx="0" cy="0"/>
+          <a:chOff x="0" y="0"/>
+          <a:chExt cx="0" cy="0"/>
+        </a:xfrm>
+      </p:grpSpPr>
       <p:sp>
         <p:nvSpPr>
           <p:cNvPr id="2" name="TextBox 1"/>
@@ -8157,6 +8010,7 @@
               </a:defRPr>
             </a:pPr>
             <a:r>
+              <a:rPr dirty="0"/>
               <a:t>AOI yield drop after CNC contouring / chamfering</a:t>
             </a:r>
           </a:p>
@@ -8172,6 +8026,7 @@
               </a:defRPr>
             </a:pPr>
             <a:r>
+              <a:rPr dirty="0"/>
               <a:t>Edge-initiated defects can feed downstream reliability risk</a:t>
             </a:r>
           </a:p>
@@ -8187,8 +8042,14 @@
               </a:defRPr>
             </a:pPr>
             <a:r>
-              <a:t>Phase 1 focus: CNC-related Edge_Chipping</a:t>
-            </a:r>
+              <a:rPr dirty="0"/>
+              <a:t>Phase 1 focus: CNC-related </a:t>
+            </a:r>
+            <a:r>
+              <a:rPr dirty="0" err="1"/>
+              <a:t>Edge_Chipping</a:t>
+            </a:r>
+            <a:endParaRPr dirty="0"/>
           </a:p>
         </p:txBody>
       </p:sp>
@@ -8236,7 +8097,7 @@
 </file>
 
 <file path=ppt/slides/slide4.xml><?xml version="1.0" encoding="utf-8"?>
-<p:sld xmlns:a="http://schemas.openxmlformats.org/drawingml/2006/main" xmlns:p="http://schemas.openxmlformats.org/presentationml/2006/main" xmlns:r="http://schemas.openxmlformats.org/officeDocument/2006/relationships">
+<p:sld xmlns:a="http://schemas.openxmlformats.org/drawingml/2006/main" xmlns:r="http://schemas.openxmlformats.org/officeDocument/2006/relationships" xmlns:p="http://schemas.openxmlformats.org/presentationml/2006/main">
   <p:cSld>
     <p:bg>
       <p:bgPr>
@@ -8252,7 +8113,14 @@
         <p:cNvGrpSpPr/>
         <p:nvPr/>
       </p:nvGrpSpPr>
-      <p:grpSpPr/>
+      <p:grpSpPr>
+        <a:xfrm>
+          <a:off x="0" y="0"/>
+          <a:ext cx="0" cy="0"/>
+          <a:chOff x="0" y="0"/>
+          <a:chExt cx="0" cy="0"/>
+        </a:xfrm>
+      </p:grpSpPr>
       <p:sp>
         <p:nvSpPr>
           <p:cNvPr id="2" name="TextBox 1"/>
@@ -8415,7 +8283,7 @@
 </file>
 
 <file path=ppt/slides/slide5.xml><?xml version="1.0" encoding="utf-8"?>
-<p:sld xmlns:a="http://schemas.openxmlformats.org/drawingml/2006/main" xmlns:p="http://schemas.openxmlformats.org/presentationml/2006/main" xmlns:r="http://schemas.openxmlformats.org/officeDocument/2006/relationships">
+<p:sld xmlns:a="http://schemas.openxmlformats.org/drawingml/2006/main" xmlns:r="http://schemas.openxmlformats.org/officeDocument/2006/relationships" xmlns:p="http://schemas.openxmlformats.org/presentationml/2006/main">
   <p:cSld>
     <p:bg>
       <p:bgPr>
@@ -8431,7 +8299,14 @@
         <p:cNvGrpSpPr/>
         <p:nvPr/>
       </p:nvGrpSpPr>
-      <p:grpSpPr/>
+      <p:grpSpPr>
+        <a:xfrm>
+          <a:off x="0" y="0"/>
+          <a:ext cx="0" cy="0"/>
+          <a:chOff x="0" y="0"/>
+          <a:chExt cx="0" cy="0"/>
+        </a:xfrm>
+      </p:grpSpPr>
       <p:sp>
         <p:nvSpPr>
           <p:cNvPr id="2" name="TextBox 1"/>
@@ -8594,7 +8469,7 @@
 </file>
 
 <file path=ppt/slides/slide6.xml><?xml version="1.0" encoding="utf-8"?>
-<p:sld xmlns:a="http://schemas.openxmlformats.org/drawingml/2006/main" xmlns:p="http://schemas.openxmlformats.org/presentationml/2006/main" xmlns:r="http://schemas.openxmlformats.org/officeDocument/2006/relationships">
+<p:sld xmlns:a="http://schemas.openxmlformats.org/drawingml/2006/main" xmlns:r="http://schemas.openxmlformats.org/officeDocument/2006/relationships" xmlns:p="http://schemas.openxmlformats.org/presentationml/2006/main">
   <p:cSld>
     <p:bg>
       <p:bgPr>
@@ -8610,7 +8485,14 @@
         <p:cNvGrpSpPr/>
         <p:nvPr/>
       </p:nvGrpSpPr>
-      <p:grpSpPr/>
+      <p:grpSpPr>
+        <a:xfrm>
+          <a:off x="0" y="0"/>
+          <a:ext cx="0" cy="0"/>
+          <a:chOff x="0" y="0"/>
+          <a:chExt cx="0" cy="0"/>
+        </a:xfrm>
+      </p:grpSpPr>
       <p:sp>
         <p:nvSpPr>
           <p:cNvPr id="2" name="TextBox 1"/>
@@ -8737,7 +8619,7 @@
         </p:nvSpPr>
         <p:spPr>
           <a:xfrm>
-            <a:off x="502920" y="4526280"/>
+            <a:off x="548640" y="5430782"/>
             <a:ext cx="4389120" cy="868680"/>
           </a:xfrm>
           <a:prstGeom prst="rect">
@@ -8767,7 +8649,7 @@
           </a:fontRef>
         </p:style>
         <p:txBody>
-          <a:bodyPr rtlCol="0" anchor="ctr" wrap="square" lIns="101600" rIns="101600" tIns="76200" bIns="76200"/>
+          <a:bodyPr wrap="square" lIns="101600" tIns="76200" rIns="101600" bIns="76200" rtlCol="0" anchor="ctr"/>
           <a:lstStyle/>
           <a:p>
             <a:pPr algn="ctr">
@@ -8777,9 +8659,7 @@
                 </a:solidFill>
               </a:defRPr>
             </a:pPr>
-            <a:r>
-              <a:t>Takeaway</a:t>
-            </a:r>
+            <a:endParaRPr dirty="0"/>
           </a:p>
           <a:p>
             <a:pPr>
@@ -8793,180 +8673,101 @@
               </a:defRPr>
             </a:pPr>
             <a:r>
+              <a:rPr dirty="0"/>
               <a:t>This is a working project — not just a slide outline.</a:t>
             </a:r>
           </a:p>
         </p:txBody>
       </p:sp>
-      <p:sp>
-        <p:nvSpPr>
-          <p:cNvPr id="5" name="Rectangle 4"/>
-          <p:cNvSpPr/>
+      <p:grpSp>
+        <p:nvGrpSpPr>
+          <p:cNvPr id="13" name="组合 12">
+            <a:extLst>
+              <a:ext uri="{FF2B5EF4-FFF2-40B4-BE49-F238E27FC236}">
+                <a16:creationId xmlns:a16="http://schemas.microsoft.com/office/drawing/2014/main" id="{0065E14A-580F-9F74-516F-E47FB72316B1}"/>
+              </a:ext>
+            </a:extLst>
+          </p:cNvPr>
+          <p:cNvGrpSpPr/>
           <p:nvPr/>
-        </p:nvSpPr>
-        <p:spPr>
-          <a:xfrm>
-            <a:off x="5074920" y="2212558"/>
-            <a:ext cx="3246120" cy="2112843"/>
-          </a:xfrm>
-          <a:prstGeom prst="rect">
-            <a:avLst/>
-          </a:prstGeom>
-          <a:noFill/>
-          <a:ln w="9525">
-            <a:solidFill>
-              <a:srgbClr val="CCCCCC"/>
-            </a:solidFill>
-          </a:ln>
-        </p:spPr>
-        <p:style>
-          <a:lnRef idx="1">
-            <a:schemeClr val="accent1"/>
-          </a:lnRef>
-          <a:fillRef idx="3">
-            <a:schemeClr val="accent1"/>
-          </a:fillRef>
-          <a:effectRef idx="2">
-            <a:schemeClr val="accent1"/>
-          </a:effectRef>
-          <a:fontRef idx="minor">
-            <a:schemeClr val="lt1"/>
-          </a:fontRef>
-        </p:style>
-        <p:txBody>
-          <a:bodyPr rtlCol="0" anchor="ctr"/>
-          <a:lstStyle/>
-          <a:p>
-            <a:pPr algn="ctr"/>
-          </a:p>
-        </p:txBody>
-      </p:sp>
-      <p:pic>
-        <p:nvPicPr>
-          <p:cNvPr id="6" name="Picture 5" descr="cursor_agent.png"/>
-          <p:cNvPicPr>
-            <a:picLocks noChangeAspect="1"/>
-          </p:cNvPicPr>
-          <p:nvPr/>
-        </p:nvPicPr>
-        <p:blipFill>
-          <a:blip r:embed="rId2"/>
-          <a:stretch>
-            <a:fillRect/>
-          </a:stretch>
-        </p:blipFill>
-        <p:spPr>
-          <a:xfrm>
-            <a:off x="5074920" y="2212558"/>
-            <a:ext cx="3246120" cy="2112843"/>
-          </a:xfrm>
-          <a:prstGeom prst="rect">
-            <a:avLst/>
-          </a:prstGeom>
-        </p:spPr>
-      </p:pic>
-      <p:sp>
-        <p:nvSpPr>
-          <p:cNvPr id="7" name="TextBox 6"/>
-          <p:cNvSpPr txBox="1"/>
-          <p:nvPr/>
-        </p:nvSpPr>
-        <p:spPr>
-          <a:xfrm>
-            <a:off x="5074920" y="5440680"/>
-            <a:ext cx="3246120" cy="320040"/>
-          </a:xfrm>
-          <a:prstGeom prst="rect">
-            <a:avLst/>
-          </a:prstGeom>
-          <a:noFill/>
-        </p:spPr>
-        <p:txBody>
-          <a:bodyPr wrap="none">
-            <a:spAutoFit/>
-          </a:bodyPr>
-          <a:lstStyle/>
-          <a:p>
-            <a:pPr algn="ctr">
-              <a:defRPr sz="1000">
-                <a:solidFill>
-                  <a:srgbClr val="666666"/>
-                </a:solidFill>
-              </a:defRPr>
-            </a:pPr>
-            <a:r>
-              <a:t>Cursor agent workflow</a:t>
-            </a:r>
-          </a:p>
-        </p:txBody>
-      </p:sp>
-      <p:sp>
-        <p:nvSpPr>
-          <p:cNvPr id="8" name="Rectangle 7"/>
-          <p:cNvSpPr/>
-          <p:nvPr/>
-        </p:nvSpPr>
-        <p:spPr>
-          <a:xfrm>
-            <a:off x="8458200" y="2327066"/>
-            <a:ext cx="3246120" cy="1883828"/>
-          </a:xfrm>
-          <a:prstGeom prst="rect">
-            <a:avLst/>
-          </a:prstGeom>
-          <a:noFill/>
-          <a:ln w="9525">
-            <a:solidFill>
-              <a:srgbClr val="CCCCCC"/>
-            </a:solidFill>
-          </a:ln>
-        </p:spPr>
-        <p:style>
-          <a:lnRef idx="1">
-            <a:schemeClr val="accent1"/>
-          </a:lnRef>
-          <a:fillRef idx="3">
-            <a:schemeClr val="accent1"/>
-          </a:fillRef>
-          <a:effectRef idx="2">
-            <a:schemeClr val="accent1"/>
-          </a:effectRef>
-          <a:fontRef idx="minor">
-            <a:schemeClr val="lt1"/>
-          </a:fontRef>
-        </p:style>
-        <p:txBody>
-          <a:bodyPr rtlCol="0" anchor="ctr"/>
-          <a:lstStyle/>
-          <a:p>
-            <a:pPr algn="ctr"/>
-          </a:p>
-        </p:txBody>
-      </p:sp>
-      <p:pic>
-        <p:nvPicPr>
-          <p:cNvPr id="9" name="Picture 8" descr="generated_50k_raw_data.png"/>
-          <p:cNvPicPr>
-            <a:picLocks noChangeAspect="1"/>
-          </p:cNvPicPr>
-          <p:nvPr/>
-        </p:nvPicPr>
-        <p:blipFill>
-          <a:blip r:embed="rId3"/>
-          <a:stretch>
-            <a:fillRect/>
-          </a:stretch>
-        </p:blipFill>
-        <p:spPr>
-          <a:xfrm>
-            <a:off x="8458200" y="2327066"/>
-            <a:ext cx="3246120" cy="1883828"/>
-          </a:xfrm>
-          <a:prstGeom prst="rect">
-            <a:avLst/>
-          </a:prstGeom>
-        </p:spPr>
-      </p:pic>
+        </p:nvGrpSpPr>
+        <p:grpSpPr>
+          <a:xfrm>
+            <a:off x="4788914" y="668832"/>
+            <a:ext cx="7268697" cy="4218259"/>
+            <a:chOff x="8458200" y="2327066"/>
+            <a:chExt cx="3246120" cy="1883828"/>
+          </a:xfrm>
+        </p:grpSpPr>
+        <p:sp>
+          <p:nvSpPr>
+            <p:cNvPr id="8" name="Rectangle 7"/>
+            <p:cNvSpPr/>
+            <p:nvPr/>
+          </p:nvSpPr>
+          <p:spPr>
+            <a:xfrm>
+              <a:off x="8458200" y="2327066"/>
+              <a:ext cx="3246120" cy="1883828"/>
+            </a:xfrm>
+            <a:prstGeom prst="rect">
+              <a:avLst/>
+            </a:prstGeom>
+            <a:noFill/>
+            <a:ln w="9525">
+              <a:solidFill>
+                <a:srgbClr val="CCCCCC"/>
+              </a:solidFill>
+            </a:ln>
+          </p:spPr>
+          <p:style>
+            <a:lnRef idx="1">
+              <a:schemeClr val="accent1"/>
+            </a:lnRef>
+            <a:fillRef idx="3">
+              <a:schemeClr val="accent1"/>
+            </a:fillRef>
+            <a:effectRef idx="2">
+              <a:schemeClr val="accent1"/>
+            </a:effectRef>
+            <a:fontRef idx="minor">
+              <a:schemeClr val="lt1"/>
+            </a:fontRef>
+          </p:style>
+          <p:txBody>
+            <a:bodyPr rtlCol="0" anchor="ctr"/>
+            <a:lstStyle/>
+            <a:p>
+              <a:pPr algn="ctr"/>
+              <a:endParaRPr/>
+            </a:p>
+          </p:txBody>
+        </p:sp>
+        <p:pic>
+          <p:nvPicPr>
+            <p:cNvPr id="9" name="Picture 8" descr="generated_50k_raw_data.png"/>
+            <p:cNvPicPr>
+              <a:picLocks noChangeAspect="1"/>
+            </p:cNvPicPr>
+            <p:nvPr/>
+          </p:nvPicPr>
+          <p:blipFill>
+            <a:blip r:embed="rId3"/>
+            <a:stretch>
+              <a:fillRect/>
+            </a:stretch>
+          </p:blipFill>
+          <p:spPr>
+            <a:xfrm>
+              <a:off x="8458200" y="2327066"/>
+              <a:ext cx="3246120" cy="1883828"/>
+            </a:xfrm>
+            <a:prstGeom prst="rect">
+              <a:avLst/>
+            </a:prstGeom>
+          </p:spPr>
+        </p:pic>
+      </p:grpSp>
       <p:sp>
         <p:nvSpPr>
           <p:cNvPr id="10" name="TextBox 9"/>
@@ -8975,7 +8776,7 @@
         </p:nvSpPr>
         <p:spPr>
           <a:xfrm>
-            <a:off x="8458200" y="5440680"/>
+            <a:off x="6835140" y="4914900"/>
             <a:ext cx="3246120" cy="320040"/>
           </a:xfrm>
           <a:prstGeom prst="rect">
@@ -9046,7 +8847,7 @@
 </file>
 
 <file path=ppt/slides/slide7.xml><?xml version="1.0" encoding="utf-8"?>
-<p:sld xmlns:a="http://schemas.openxmlformats.org/drawingml/2006/main" xmlns:p="http://schemas.openxmlformats.org/presentationml/2006/main" xmlns:r="http://schemas.openxmlformats.org/officeDocument/2006/relationships">
+<p:sld xmlns:a="http://schemas.openxmlformats.org/drawingml/2006/main" xmlns:r="http://schemas.openxmlformats.org/officeDocument/2006/relationships" xmlns:p="http://schemas.openxmlformats.org/presentationml/2006/main">
   <p:cSld>
     <p:bg>
       <p:bgPr>
@@ -9062,7 +8863,14 @@
         <p:cNvGrpSpPr/>
         <p:nvPr/>
       </p:nvGrpSpPr>
-      <p:grpSpPr/>
+      <p:grpSpPr>
+        <a:xfrm>
+          <a:off x="0" y="0"/>
+          <a:ext cx="0" cy="0"/>
+          <a:chOff x="0" y="0"/>
+          <a:chExt cx="0" cy="0"/>
+        </a:xfrm>
+      </p:grpSpPr>
       <p:sp>
         <p:nvSpPr>
           <p:cNvPr id="2" name="TextBox 1"/>
@@ -9173,6 +8981,7 @@
           <a:lstStyle/>
           <a:p>
             <a:pPr algn="ctr"/>
+            <a:endParaRPr/>
           </a:p>
         </p:txBody>
       </p:sp>
@@ -9185,7 +8994,7 @@
           <p:nvPr/>
         </p:nvPicPr>
         <p:blipFill>
-          <a:blip r:embed="rId2"/>
+          <a:blip r:embed="rId3"/>
           <a:stretch>
             <a:fillRect/>
           </a:stretch>
@@ -9275,6 +9084,7 @@
           <a:lstStyle/>
           <a:p>
             <a:pPr algn="ctr"/>
+            <a:endParaRPr/>
           </a:p>
         </p:txBody>
       </p:sp>
@@ -9287,7 +9097,7 @@
           <p:nvPr/>
         </p:nvPicPr>
         <p:blipFill>
-          <a:blip r:embed="rId3"/>
+          <a:blip r:embed="rId4"/>
           <a:stretch>
             <a:fillRect/>
           </a:stretch>
@@ -9377,6 +9187,7 @@
           <a:lstStyle/>
           <a:p>
             <a:pPr algn="ctr"/>
+            <a:endParaRPr/>
           </a:p>
         </p:txBody>
       </p:sp>
@@ -9389,7 +9200,7 @@
           <p:nvPr/>
         </p:nvPicPr>
         <p:blipFill>
-          <a:blip r:embed="rId4"/>
+          <a:blip r:embed="rId5"/>
           <a:stretch>
             <a:fillRect/>
           </a:stretch>
@@ -9572,7 +9383,7 @@
 </file>
 
 <file path=ppt/slides/slide8.xml><?xml version="1.0" encoding="utf-8"?>
-<p:sld xmlns:a="http://schemas.openxmlformats.org/drawingml/2006/main" xmlns:p="http://schemas.openxmlformats.org/presentationml/2006/main" xmlns:r="http://schemas.openxmlformats.org/officeDocument/2006/relationships">
+<p:sld xmlns:a="http://schemas.openxmlformats.org/drawingml/2006/main" xmlns:r="http://schemas.openxmlformats.org/officeDocument/2006/relationships" xmlns:p="http://schemas.openxmlformats.org/presentationml/2006/main">
   <p:cSld>
     <p:bg>
       <p:bgPr>
@@ -9588,7 +9399,14 @@
         <p:cNvGrpSpPr/>
         <p:nvPr/>
       </p:nvGrpSpPr>
-      <p:grpSpPr/>
+      <p:grpSpPr>
+        <a:xfrm>
+          <a:off x="0" y="0"/>
+          <a:ext cx="0" cy="0"/>
+          <a:chOff x="0" y="0"/>
+          <a:chExt cx="0" cy="0"/>
+        </a:xfrm>
+      </p:grpSpPr>
       <p:sp>
         <p:nvSpPr>
           <p:cNvPr id="2" name="TextBox 1"/>
@@ -9745,7 +9563,7 @@
           </a:fontRef>
         </p:style>
         <p:txBody>
-          <a:bodyPr rtlCol="0" anchor="ctr" wrap="square" lIns="101600" rIns="101600" tIns="76200" bIns="76200"/>
+          <a:bodyPr wrap="square" lIns="101600" tIns="76200" rIns="101600" bIns="76200" rtlCol="0" anchor="ctr"/>
           <a:lstStyle/>
           <a:p>
             <a:pPr algn="ctr">
@@ -9755,9 +9573,7 @@
                 </a:solidFill>
               </a:defRPr>
             </a:pPr>
-            <a:r>
-              <a:t>Takeaway</a:t>
-            </a:r>
+            <a:endParaRPr dirty="0"/>
           </a:p>
           <a:p>
             <a:pPr>
@@ -9771,6 +9587,7 @@
               </a:defRPr>
             </a:pPr>
             <a:r>
+              <a:rPr dirty="0"/>
               <a:t>Edge chipping dominates — start there before chasing minor modes.</a:t>
             </a:r>
           </a:p>
@@ -9816,6 +9633,7 @@
           <a:lstStyle/>
           <a:p>
             <a:pPr algn="ctr"/>
+            <a:endParaRPr/>
           </a:p>
         </p:txBody>
       </p:sp>
@@ -9828,7 +9646,7 @@
           <p:nvPr/>
         </p:nvPicPr>
         <p:blipFill>
-          <a:blip r:embed="rId2"/>
+          <a:blip r:embed="rId3"/>
           <a:stretch>
             <a:fillRect/>
           </a:stretch>
@@ -9922,7 +9740,7 @@
 </file>
 
 <file path=ppt/slides/slide9.xml><?xml version="1.0" encoding="utf-8"?>
-<p:sld xmlns:a="http://schemas.openxmlformats.org/drawingml/2006/main" xmlns:p="http://schemas.openxmlformats.org/presentationml/2006/main" xmlns:r="http://schemas.openxmlformats.org/officeDocument/2006/relationships">
+<p:sld xmlns:a="http://schemas.openxmlformats.org/drawingml/2006/main" xmlns:r="http://schemas.openxmlformats.org/officeDocument/2006/relationships" xmlns:p="http://schemas.openxmlformats.org/presentationml/2006/main">
   <p:cSld>
     <p:bg>
       <p:bgPr>
@@ -9938,7 +9756,14 @@
         <p:cNvGrpSpPr/>
         <p:nvPr/>
       </p:nvGrpSpPr>
-      <p:grpSpPr/>
+      <p:grpSpPr>
+        <a:xfrm>
+          <a:off x="0" y="0"/>
+          <a:ext cx="0" cy="0"/>
+          <a:chOff x="0" y="0"/>
+          <a:chExt cx="0" cy="0"/>
+        </a:xfrm>
+      </p:grpSpPr>
       <p:sp>
         <p:nvSpPr>
           <p:cNvPr id="2" name="TextBox 1"/>
@@ -10406,7 +10231,7 @@
 </file>
 
 <file path=ppt/theme/theme2.xml><?xml version="1.0" encoding="utf-8"?>
-<a:theme xmlns:a="http://schemas.openxmlformats.org/drawingml/2006/main" name="Office Theme">
+<a:theme xmlns:a="http://schemas.openxmlformats.org/drawingml/2006/main" name="Office 主题​​">
   <a:themeElements>
     <a:clrScheme name="Office">
       <a:dk1>
@@ -10416,44 +10241,44 @@
         <a:sysClr val="window" lastClr="FFFFFF"/>
       </a:lt1>
       <a:dk2>
-        <a:srgbClr val="1F497D"/>
+        <a:srgbClr val="0E2841"/>
       </a:dk2>
       <a:lt2>
-        <a:srgbClr val="EEECE1"/>
+        <a:srgbClr val="E8E8E8"/>
       </a:lt2>
       <a:accent1>
-        <a:srgbClr val="4F81BD"/>
+        <a:srgbClr val="156082"/>
       </a:accent1>
       <a:accent2>
-        <a:srgbClr val="C0504D"/>
+        <a:srgbClr val="E97132"/>
       </a:accent2>
       <a:accent3>
-        <a:srgbClr val="9BBB59"/>
+        <a:srgbClr val="196B24"/>
       </a:accent3>
       <a:accent4>
-        <a:srgbClr val="8064A2"/>
+        <a:srgbClr val="0F9ED5"/>
       </a:accent4>
       <a:accent5>
-        <a:srgbClr val="4BACC6"/>
+        <a:srgbClr val="A02B93"/>
       </a:accent5>
       <a:accent6>
-        <a:srgbClr val="F79646"/>
+        <a:srgbClr val="4EA72E"/>
       </a:accent6>
       <a:hlink>
-        <a:srgbClr val="0000FF"/>
+        <a:srgbClr val="467886"/>
       </a:hlink>
       <a:folHlink>
-        <a:srgbClr val="800080"/>
+        <a:srgbClr val="96607D"/>
       </a:folHlink>
     </a:clrScheme>
     <a:fontScheme name="Office">
       <a:majorFont>
-        <a:latin typeface="Calibri"/>
+        <a:latin typeface="等线 Light" panose="02110004020202020204"/>
         <a:ea typeface=""/>
         <a:cs typeface=""/>
-        <a:font script="Jpan" typeface="ＭＳ Ｐゴシック"/>
+        <a:font script="Jpan" typeface="游ゴシック Light"/>
         <a:font script="Hang" typeface="맑은 고딕"/>
-        <a:font script="Hans" typeface="宋体"/>
+        <a:font script="Hans" typeface="等线 Light"/>
         <a:font script="Hant" typeface="新細明體"/>
         <a:font script="Arab" typeface="Times New Roman"/>
         <a:font script="Hebr" typeface="Times New Roman"/>
@@ -10481,14 +10306,31 @@
         <a:font script="Viet" typeface="Times New Roman"/>
         <a:font script="Uigh" typeface="Microsoft Uighur"/>
         <a:font script="Geor" typeface="Sylfaen"/>
+        <a:font script="Armn" typeface="Arial"/>
+        <a:font script="Bugi" typeface="Leelawadee UI"/>
+        <a:font script="Bopo" typeface="Microsoft JhengHei"/>
+        <a:font script="Java" typeface="Javanese Text"/>
+        <a:font script="Lisu" typeface="Segoe UI"/>
+        <a:font script="Mymr" typeface="Myanmar Text"/>
+        <a:font script="Nkoo" typeface="Ebrima"/>
+        <a:font script="Olck" typeface="Nirmala UI"/>
+        <a:font script="Osma" typeface="Ebrima"/>
+        <a:font script="Phag" typeface="Phagspa"/>
+        <a:font script="Syrn" typeface="Estrangelo Edessa"/>
+        <a:font script="Syrj" typeface="Estrangelo Edessa"/>
+        <a:font script="Syre" typeface="Estrangelo Edessa"/>
+        <a:font script="Sora" typeface="Nirmala UI"/>
+        <a:font script="Tale" typeface="Microsoft Tai Le"/>
+        <a:font script="Talu" typeface="Microsoft New Tai Lue"/>
+        <a:font script="Tfng" typeface="Ebrima"/>
       </a:majorFont>
       <a:minorFont>
-        <a:latin typeface="Calibri"/>
+        <a:latin typeface="等线" panose="02110004020202020204"/>
         <a:ea typeface=""/>
         <a:cs typeface=""/>
-        <a:font script="Jpan" typeface="ＭＳ Ｐゴシック"/>
+        <a:font script="Jpan" typeface="游ゴシック"/>
         <a:font script="Hang" typeface="맑은 고딕"/>
-        <a:font script="Hans" typeface="宋体"/>
+        <a:font script="Hans" typeface="等线"/>
         <a:font script="Hant" typeface="新細明體"/>
         <a:font script="Arab" typeface="Arial"/>
         <a:font script="Hebr" typeface="Arial"/>
@@ -10516,6 +10358,23 @@
         <a:font script="Viet" typeface="Arial"/>
         <a:font script="Uigh" typeface="Microsoft Uighur"/>
         <a:font script="Geor" typeface="Sylfaen"/>
+        <a:font script="Armn" typeface="Arial"/>
+        <a:font script="Bugi" typeface="Leelawadee UI"/>
+        <a:font script="Bopo" typeface="Microsoft JhengHei"/>
+        <a:font script="Java" typeface="Javanese Text"/>
+        <a:font script="Lisu" typeface="Segoe UI"/>
+        <a:font script="Mymr" typeface="Myanmar Text"/>
+        <a:font script="Nkoo" typeface="Ebrima"/>
+        <a:font script="Olck" typeface="Nirmala UI"/>
+        <a:font script="Osma" typeface="Ebrima"/>
+        <a:font script="Phag" typeface="Phagspa"/>
+        <a:font script="Syrn" typeface="Estrangelo Edessa"/>
+        <a:font script="Syrj" typeface="Estrangelo Edessa"/>
+        <a:font script="Syre" typeface="Estrangelo Edessa"/>
+        <a:font script="Sora" typeface="Nirmala UI"/>
+        <a:font script="Tale" typeface="Microsoft Tai Le"/>
+        <a:font script="Talu" typeface="Microsoft New Tai Lue"/>
+        <a:font script="Tfng" typeface="Ebrima"/>
       </a:minorFont>
     </a:fontScheme>
     <a:fmtScheme name="Office">
@@ -10527,180 +10386,136 @@
           <a:gsLst>
             <a:gs pos="0">
               <a:schemeClr val="phClr">
-                <a:tint val="50000"/>
-                <a:satMod val="300000"/>
+                <a:lumMod val="110000"/>
+                <a:satMod val="105000"/>
+                <a:tint val="67000"/>
               </a:schemeClr>
             </a:gs>
-            <a:gs pos="35000">
+            <a:gs pos="50000">
               <a:schemeClr val="phClr">
-                <a:tint val="37000"/>
-                <a:satMod val="300000"/>
+                <a:lumMod val="105000"/>
+                <a:satMod val="103000"/>
+                <a:tint val="73000"/>
               </a:schemeClr>
             </a:gs>
             <a:gs pos="100000">
               <a:schemeClr val="phClr">
-                <a:tint val="15000"/>
-                <a:satMod val="350000"/>
+                <a:lumMod val="105000"/>
+                <a:satMod val="109000"/>
+                <a:tint val="81000"/>
               </a:schemeClr>
             </a:gs>
           </a:gsLst>
-          <a:lin ang="16200000" scaled="1"/>
+          <a:lin ang="5400000" scaled="0"/>
         </a:gradFill>
         <a:gradFill rotWithShape="1">
           <a:gsLst>
             <a:gs pos="0">
               <a:schemeClr val="phClr">
-                <a:tint val="100000"/>
+                <a:satMod val="103000"/>
+                <a:lumMod val="102000"/>
+                <a:tint val="94000"/>
+              </a:schemeClr>
+            </a:gs>
+            <a:gs pos="50000">
+              <a:schemeClr val="phClr">
+                <a:satMod val="110000"/>
+                <a:lumMod val="100000"/>
                 <a:shade val="100000"/>
-                <a:satMod val="130000"/>
               </a:schemeClr>
             </a:gs>
             <a:gs pos="100000">
               <a:schemeClr val="phClr">
-                <a:tint val="50000"/>
-                <a:shade val="100000"/>
-                <a:satMod val="350000"/>
+                <a:lumMod val="99000"/>
+                <a:satMod val="120000"/>
+                <a:shade val="78000"/>
               </a:schemeClr>
             </a:gs>
           </a:gsLst>
-          <a:lin ang="16200000" scaled="0"/>
+          <a:lin ang="5400000" scaled="0"/>
         </a:gradFill>
       </a:fillStyleLst>
       <a:lnStyleLst>
-        <a:ln w="9525" cap="flat" cmpd="sng" algn="ctr">
+        <a:ln w="12700" cap="flat" cmpd="sng" algn="ctr">
           <a:solidFill>
-            <a:schemeClr val="phClr">
-              <a:shade val="95000"/>
-              <a:satMod val="105000"/>
-            </a:schemeClr>
+            <a:schemeClr val="phClr"/>
           </a:solidFill>
           <a:prstDash val="solid"/>
+          <a:miter lim="800000"/>
+        </a:ln>
+        <a:ln w="19050" cap="flat" cmpd="sng" algn="ctr">
+          <a:solidFill>
+            <a:schemeClr val="phClr"/>
+          </a:solidFill>
+          <a:prstDash val="solid"/>
+          <a:miter lim="800000"/>
         </a:ln>
         <a:ln w="25400" cap="flat" cmpd="sng" algn="ctr">
           <a:solidFill>
             <a:schemeClr val="phClr"/>
           </a:solidFill>
           <a:prstDash val="solid"/>
-        </a:ln>
-        <a:ln w="38100" cap="flat" cmpd="sng" algn="ctr">
-          <a:solidFill>
-            <a:schemeClr val="phClr"/>
-          </a:solidFill>
-          <a:prstDash val="solid"/>
+          <a:miter lim="800000"/>
         </a:ln>
       </a:lnStyleLst>
       <a:effectStyleLst>
         <a:effectStyle>
+          <a:effectLst/>
+        </a:effectStyle>
+        <a:effectStyle>
+          <a:effectLst/>
+        </a:effectStyle>
+        <a:effectStyle>
           <a:effectLst>
-            <a:outerShdw blurRad="40000" dist="20000" dir="5400000" rotWithShape="0">
+            <a:outerShdw blurRad="57150" dist="19050" dir="5400000" algn="ctr" rotWithShape="0">
               <a:srgbClr val="000000">
-                <a:alpha val="38000"/>
+                <a:alpha val="63000"/>
               </a:srgbClr>
             </a:outerShdw>
           </a:effectLst>
-        </a:effectStyle>
-        <a:effectStyle>
-          <a:effectLst>
-            <a:outerShdw blurRad="40000" dist="23000" dir="5400000" rotWithShape="0">
-              <a:srgbClr val="000000">
-                <a:alpha val="35000"/>
-              </a:srgbClr>
-            </a:outerShdw>
-          </a:effectLst>
-        </a:effectStyle>
-        <a:effectStyle>
-          <a:effectLst>
-            <a:outerShdw blurRad="40000" dist="23000" dir="5400000" rotWithShape="0">
-              <a:srgbClr val="000000">
-                <a:alpha val="35000"/>
-              </a:srgbClr>
-            </a:outerShdw>
-          </a:effectLst>
-          <a:scene3d>
-            <a:camera prst="orthographicFront">
-              <a:rot lat="0" lon="0" rev="0"/>
-            </a:camera>
-            <a:lightRig rig="threePt" dir="t">
-              <a:rot lat="0" lon="0" rev="1200000"/>
-            </a:lightRig>
-          </a:scene3d>
-          <a:sp3d>
-            <a:bevelT w="63500" h="25400"/>
-          </a:sp3d>
         </a:effectStyle>
       </a:effectStyleLst>
       <a:bgFillStyleLst>
         <a:solidFill>
           <a:schemeClr val="phClr"/>
         </a:solidFill>
+        <a:solidFill>
+          <a:schemeClr val="phClr">
+            <a:tint val="95000"/>
+            <a:satMod val="170000"/>
+          </a:schemeClr>
+        </a:solidFill>
         <a:gradFill rotWithShape="1">
           <a:gsLst>
             <a:gs pos="0">
               <a:schemeClr val="phClr">
-                <a:tint val="40000"/>
-                <a:satMod val="350000"/>
+                <a:tint val="93000"/>
+                <a:satMod val="150000"/>
+                <a:shade val="98000"/>
+                <a:lumMod val="102000"/>
               </a:schemeClr>
             </a:gs>
-            <a:gs pos="40000">
+            <a:gs pos="50000">
               <a:schemeClr val="phClr">
-                <a:tint val="45000"/>
-                <a:shade val="99000"/>
-                <a:satMod val="350000"/>
+                <a:tint val="98000"/>
+                <a:satMod val="130000"/>
+                <a:shade val="90000"/>
+                <a:lumMod val="103000"/>
               </a:schemeClr>
             </a:gs>
             <a:gs pos="100000">
               <a:schemeClr val="phClr">
-                <a:shade val="20000"/>
-                <a:satMod val="255000"/>
+                <a:shade val="63000"/>
+                <a:satMod val="120000"/>
               </a:schemeClr>
             </a:gs>
           </a:gsLst>
-          <a:path path="circle">
-            <a:fillToRect l="50000" t="-80000" r="50000" b="180000"/>
-          </a:path>
-        </a:gradFill>
-        <a:gradFill rotWithShape="1">
-          <a:gsLst>
-            <a:gs pos="0">
-              <a:schemeClr val="phClr">
-                <a:tint val="80000"/>
-                <a:satMod val="300000"/>
-              </a:schemeClr>
-            </a:gs>
-            <a:gs pos="100000">
-              <a:schemeClr val="phClr">
-                <a:shade val="30000"/>
-                <a:satMod val="200000"/>
-              </a:schemeClr>
-            </a:gs>
-          </a:gsLst>
-          <a:path path="circle">
-            <a:fillToRect l="50000" t="50000" r="50000" b="50000"/>
-          </a:path>
+          <a:lin ang="5400000" scaled="0"/>
         </a:gradFill>
       </a:bgFillStyleLst>
     </a:fmtScheme>
   </a:themeElements>
   <a:objectDefaults>
-    <a:spDef>
-      <a:spPr/>
-      <a:bodyPr/>
-      <a:lstStyle/>
-      <a:style>
-        <a:lnRef idx="1">
-          <a:schemeClr val="accent1"/>
-        </a:lnRef>
-        <a:fillRef idx="3">
-          <a:schemeClr val="accent1"/>
-        </a:fillRef>
-        <a:effectRef idx="2">
-          <a:schemeClr val="accent1"/>
-        </a:effectRef>
-        <a:fontRef idx="minor">
-          <a:schemeClr val="lt1"/>
-        </a:fontRef>
-      </a:style>
-    </a:spDef>
     <a:lnDef>
       <a:spPr/>
       <a:bodyPr/>
@@ -10722,5 +10537,10 @@
     </a:lnDef>
   </a:objectDefaults>
   <a:extraClrSchemeLst/>
+  <a:extLst>
+    <a:ext uri="{05A4C25C-085E-4340-85A3-A5531E510DB2}">
+      <thm15:themeFamily xmlns:thm15="http://schemas.microsoft.com/office/thememl/2012/main" name="Office Theme" id="{2E142A2C-CD16-42D6-873A-C26D2A0506FA}" vid="{1BDDFF52-6CD6-40A5-AB3C-68EB2F1E4D0A}"/>
+    </a:ext>
+  </a:extLst>
 </a:theme>
 </file>
</xml_diff>